<commit_message>
Pengembangan akses strutural dan IT
</commit_message>
<xml_diff>
--- a/docs/PRESENTASI_GOOGLE_SHEET_AI.pptx
+++ b/docs/PRESENTASI_GOOGLE_SHEET_AI.pptx
@@ -24,6 +24,8 @@
     <p:sldId id="272" r:id="rId24"/>
     <p:sldId id="273" r:id="rId25"/>
     <p:sldId id="274" r:id="rId26"/>
+    <p:sldId id="275" r:id="rId27"/>
+    <p:sldId id="276" r:id="rId28"/>
   </p:sldIdLst>
   <p:sldSz cx="12191695" cy="6858000" type="screen4x3"/>
   <p:notesSz cx="6858000" cy="9144000"/>
@@ -1220,7 +1222,7 @@
           <a:lstStyle/>
           <a:p>
             <a:r>
-              <a:t>Akhiri dengan lima kata kerja. Saat diskusi lanjut, arahkan audiens ke panduan pengguna dan status akses BE16; gunakan deck sebagai pengantar, bukan spesifikasi teknis lengkap.</a:t>
+              <a:t>Contoh fiktif. Admin dapat memberikan beberapa unit sekaligus lewat Administrasi. Untuk setiap sumber, admin menunjuk reviewer metadata, konfigurasi, dan batch import secara terpisah. Penunjukan tidak menggantikan policy akses; reviewer harus aktif dan tidak boleh menyetujui pekerjaannya sendiri. Sumber lama yang belum dikonfigurasi masih memakai pemeriksaan role lama sampai daftar reviewer disimpan.</a:t>
             </a:r>
           </a:p>
         </p:txBody>
@@ -1291,6 +1293,146 @@
           <a:p>
             <a:r>
               <a:t>Mulai dari masalah yang dialami pengguna: bukan kekurangan spreadsheet, melainkan kurangnya jejak perubahan, makna kolom, dan akses yang konsisten. Hindari klaim bahwa semua file otomatis menjadi tabel baru.</a:t>
+            </a:r>
+          </a:p>
+        </p:txBody>
+      </p:sp>
+      <p:sp>
+        <p:nvSpPr>
+          <p:cNvPr id="4" name="Slide Number Placeholder 3"/>
+          <p:cNvSpPr>
+            <a:spLocks noGrp="1"/>
+          </p:cNvSpPr>
+          <p:nvPr>
+            <p:ph type="sldNum" idx="5" sz="quarter"/>
+          </p:nvPr>
+        </p:nvSpPr>
+        <p:spPr/>
+      </p:sp>
+    </p:spTree>
+  </p:cSld>
+  <p:clrMapOvr>
+    <a:masterClrMapping/>
+  </p:clrMapOvr>
+</p:notes>
+</file>
+
+<file path=ppt/notesSlides/notesSlide20.xml><?xml version="1.0" encoding="utf-8"?>
+<p:notes xmlns:a="http://schemas.openxmlformats.org/drawingml/2006/main" xmlns:p="http://schemas.openxmlformats.org/presentationml/2006/main" xmlns:r="http://schemas.openxmlformats.org/officeDocument/2006/relationships">
+  <p:cSld>
+    <p:spTree>
+      <p:nvGrpSpPr>
+        <p:cNvPr id="1" name=""/>
+        <p:cNvGrpSpPr/>
+        <p:nvPr/>
+      </p:nvGrpSpPr>
+      <p:grpSpPr>
+        <a:xfrm>
+          <a:off x="0" y="0"/>
+          <a:ext cx="0" cy="0"/>
+          <a:chOff x="0" y="0"/>
+          <a:chExt cx="0" cy="0"/>
+        </a:xfrm>
+      </p:grpSpPr>
+      <p:sp>
+        <p:nvSpPr>
+          <p:cNvPr id="2" name="Slide Image Placeholder 1"/>
+          <p:cNvSpPr>
+            <a:spLocks noGrp="1"/>
+          </p:cNvSpPr>
+          <p:nvPr>
+            <p:ph type="sldImg" idx="2"/>
+          </p:nvPr>
+        </p:nvSpPr>
+        <p:spPr/>
+      </p:sp>
+      <p:sp>
+        <p:nvSpPr>
+          <p:cNvPr id="3" name="Notes Placeholder 2"/>
+          <p:cNvSpPr>
+            <a:spLocks noGrp="1"/>
+          </p:cNvSpPr>
+          <p:nvPr>
+            <p:ph type="body" idx="3" sz="quarter"/>
+          </p:nvPr>
+        </p:nvSpPr>
+        <p:spPr/>
+        <p:txBody>
+          <a:bodyPr/>
+          <a:lstStyle/>
+          <a:p>
+            <a:r>
+              <a:t>Admin memilih akun IT dan unit terkait dari daftar. Approver unit wajib memiliki assignment aktif, tetapi penunjukan approval tidak memberi hak query. Jika revisi konfigurasi atau aturan rilis berubah, keputusan lama tidak berlaku. Gate diperiksa pada antrean dan worker deploy; batch import berikutnya tetap mengikuti review batch tersendiri.</a:t>
+            </a:r>
+          </a:p>
+        </p:txBody>
+      </p:sp>
+      <p:sp>
+        <p:nvSpPr>
+          <p:cNvPr id="4" name="Slide Number Placeholder 3"/>
+          <p:cNvSpPr>
+            <a:spLocks noGrp="1"/>
+          </p:cNvSpPr>
+          <p:nvPr>
+            <p:ph type="sldNum" idx="5" sz="quarter"/>
+          </p:nvPr>
+        </p:nvSpPr>
+        <p:spPr/>
+      </p:sp>
+    </p:spTree>
+  </p:cSld>
+  <p:clrMapOvr>
+    <a:masterClrMapping/>
+  </p:clrMapOvr>
+</p:notes>
+</file>
+
+<file path=ppt/notesSlides/notesSlide21.xml><?xml version="1.0" encoding="utf-8"?>
+<p:notes xmlns:a="http://schemas.openxmlformats.org/drawingml/2006/main" xmlns:p="http://schemas.openxmlformats.org/presentationml/2006/main" xmlns:r="http://schemas.openxmlformats.org/officeDocument/2006/relationships">
+  <p:cSld>
+    <p:spTree>
+      <p:nvGrpSpPr>
+        <p:cNvPr id="1" name=""/>
+        <p:cNvGrpSpPr/>
+        <p:nvPr/>
+      </p:nvGrpSpPr>
+      <p:grpSpPr>
+        <a:xfrm>
+          <a:off x="0" y="0"/>
+          <a:ext cx="0" cy="0"/>
+          <a:chOff x="0" y="0"/>
+          <a:chExt cx="0" cy="0"/>
+        </a:xfrm>
+      </p:grpSpPr>
+      <p:sp>
+        <p:nvSpPr>
+          <p:cNvPr id="2" name="Slide Image Placeholder 1"/>
+          <p:cNvSpPr>
+            <a:spLocks noGrp="1"/>
+          </p:cNvSpPr>
+          <p:nvPr>
+            <p:ph type="sldImg" idx="2"/>
+          </p:nvPr>
+        </p:nvSpPr>
+        <p:spPr/>
+      </p:sp>
+      <p:sp>
+        <p:nvSpPr>
+          <p:cNvPr id="3" name="Notes Placeholder 2"/>
+          <p:cNvSpPr>
+            <a:spLocks noGrp="1"/>
+          </p:cNvSpPr>
+          <p:nvPr>
+            <p:ph type="body" idx="3" sz="quarter"/>
+          </p:nvPr>
+        </p:nvSpPr>
+        <p:spPr/>
+        <p:txBody>
+          <a:bodyPr/>
+          <a:lstStyle/>
+          <a:p>
+            <a:r>
+              <a:t>Akhiri dengan lima kata kerja. Saat diskusi lanjut, arahkan audiens ke panduan pengguna dan status akses BE16; gunakan deck sebagai pengantar, bukan spesifikasi teknis lengkap.</a:t>
             </a:r>
           </a:p>
         </p:txBody>
@@ -15872,7 +16014,7 @@
             <a:avLst/>
           </a:prstGeom>
           <a:solidFill>
-            <a:srgbClr val="0C1C29"/>
+            <a:srgbClr val="F7F9F5"/>
           </a:solidFill>
           <a:ln>
             <a:noFill/>
@@ -15902,93 +16044,7 @@
       </p:sp>
       <p:sp>
         <p:nvSpPr>
-          <p:cNvPr id="3" name="Oval 2"/>
-          <p:cNvSpPr/>
-          <p:nvPr/>
-        </p:nvSpPr>
-        <p:spPr>
-          <a:xfrm>
-            <a:off x="9235440" y="-1097280"/>
-            <a:ext cx="4023360" cy="4023360"/>
-          </a:xfrm>
-          <a:prstGeom prst="ellipse">
-            <a:avLst/>
-          </a:prstGeom>
-          <a:solidFill>
-            <a:srgbClr val="122B37"/>
-          </a:solidFill>
-          <a:ln>
-            <a:noFill/>
-          </a:ln>
-        </p:spPr>
-        <p:style>
-          <a:lnRef idx="1">
-            <a:schemeClr val="accent1"/>
-          </a:lnRef>
-          <a:fillRef idx="3">
-            <a:schemeClr val="accent1"/>
-          </a:fillRef>
-          <a:effectRef idx="2">
-            <a:schemeClr val="accent1"/>
-          </a:effectRef>
-          <a:fontRef idx="minor">
-            <a:schemeClr val="lt1"/>
-          </a:fontRef>
-        </p:style>
-        <p:txBody>
-          <a:bodyPr rtlCol="0" anchor="ctr"/>
-          <a:lstStyle/>
-          <a:p>
-            <a:pPr algn="ctr"/>
-          </a:p>
-        </p:txBody>
-      </p:sp>
-      <p:sp>
-        <p:nvSpPr>
-          <p:cNvPr id="4" name="Oval 3"/>
-          <p:cNvSpPr/>
-          <p:nvPr/>
-        </p:nvSpPr>
-        <p:spPr>
-          <a:xfrm>
-            <a:off x="-1097280" y="5303520"/>
-            <a:ext cx="2926080" cy="2926080"/>
-          </a:xfrm>
-          <a:prstGeom prst="ellipse">
-            <a:avLst/>
-          </a:prstGeom>
-          <a:solidFill>
-            <a:srgbClr val="122B37"/>
-          </a:solidFill>
-          <a:ln>
-            <a:noFill/>
-          </a:ln>
-        </p:spPr>
-        <p:style>
-          <a:lnRef idx="1">
-            <a:schemeClr val="accent1"/>
-          </a:lnRef>
-          <a:fillRef idx="3">
-            <a:schemeClr val="accent1"/>
-          </a:fillRef>
-          <a:effectRef idx="2">
-            <a:schemeClr val="accent1"/>
-          </a:effectRef>
-          <a:fontRef idx="minor">
-            <a:schemeClr val="lt1"/>
-          </a:fontRef>
-        </p:style>
-        <p:txBody>
-          <a:bodyPr rtlCol="0" anchor="ctr"/>
-          <a:lstStyle/>
-          <a:p>
-            <a:pPr algn="ctr"/>
-          </a:p>
-        </p:txBody>
-      </p:sp>
-      <p:sp>
-        <p:nvSpPr>
-          <p:cNvPr id="5" name="TextBox 4"/>
+          <p:cNvPr id="3" name="TextBox 2"/>
           <p:cNvSpPr txBox="1"/>
           <p:nvPr/>
         </p:nvSpPr>
@@ -16019,18 +16075,18 @@
             <a:r>
               <a:rPr sz="1050" b="1">
                 <a:solidFill>
-                  <a:srgbClr val="CCEEE2"/>
-                </a:solidFill>
-                <a:latin typeface="Aptos"/>
-              </a:rPr>
-              <a:t>PENUTUP</a:t>
-            </a:r>
-          </a:p>
-        </p:txBody>
-      </p:sp>
-      <p:sp>
-        <p:nvSpPr>
-          <p:cNvPr id="6" name="TextBox 5"/>
+                  <a:srgbClr val="096752"/>
+                </a:solidFill>
+                <a:latin typeface="Aptos"/>
+              </a:rPr>
+              <a:t>TATA KELOLA · KEPUTUSAN</a:t>
+            </a:r>
+          </a:p>
+        </p:txBody>
+      </p:sp>
+      <p:sp>
+        <p:nvSpPr>
+          <p:cNvPr id="4" name="TextBox 3"/>
           <p:cNvSpPr txBox="1"/>
           <p:nvPr/>
         </p:nvSpPr>
@@ -16061,18 +16117,60 @@
             <a:r>
               <a:rPr sz="2800" b="1">
                 <a:solidFill>
-                  <a:srgbClr val="FFFFFF"/>
-                </a:solidFill>
-                <a:latin typeface="Aptos"/>
-              </a:rPr>
-              <a:t>Pesan utama</a:t>
+                  <a:srgbClr val="1A2F37"/>
+                </a:solidFill>
+                <a:latin typeface="Aptos"/>
+              </a:rPr>
+              <a:t>Akses multi-unit dan approver</a:t>
+            </a:r>
+          </a:p>
+        </p:txBody>
+      </p:sp>
+      <p:sp>
+        <p:nvSpPr>
+          <p:cNvPr id="5" name="TextBox 4"/>
+          <p:cNvSpPr txBox="1"/>
+          <p:nvPr/>
+        </p:nvSpPr>
+        <p:spPr>
+          <a:xfrm>
+            <a:off x="685800" y="1362456"/>
+            <a:ext cx="10744200" cy="438912"/>
+          </a:xfrm>
+          <a:prstGeom prst="rect">
+            <a:avLst/>
+          </a:prstGeom>
+          <a:noFill/>
+        </p:spPr>
+        <p:txBody>
+          <a:bodyPr wrap="square" lIns="27432" rIns="27432" tIns="27432" bIns="27432" anchor="ctr">
+            <a:spAutoFit/>
+          </a:bodyPr>
+          <a:lstStyle/>
+          <a:p>
+            <a:pPr algn="l">
+              <a:lnSpc>
+                <a:spcPct val="108000"/>
+              </a:lnSpc>
+              <a:spcAft>
+                <a:spcPts val="0"/>
+              </a:spcAft>
+            </a:pPr>
+            <a:r>
+              <a:rPr sz="1300" b="0">
+                <a:solidFill>
+                  <a:srgbClr val="586C71"/>
+                </a:solidFill>
+                <a:latin typeface="Aptos"/>
+              </a:rPr>
+              <a:t>Daftar unit untuk melihat data; daftar reviewer untuk keputusan pada sumber.</a:t>
             </a:r>
           </a:p>
         </p:txBody>
       </p:sp>
       <p:cxnSp>
         <p:nvCxnSpPr>
-          <p:cNvPr id="7" name="Connector 6"/>
+          <p:cNvPr id="6" name="Connector 5"/>
           <p:cNvCxnSpPr/>
           <p:nvPr/>
         </p:nvCxnSpPr>
@@ -16086,7 +16184,7 @@
           </a:prstGeom>
           <a:ln w="16510">
             <a:solidFill>
-              <a:srgbClr val="4D6868"/>
+              <a:srgbClr val="DBE6E2"/>
             </a:solidFill>
           </a:ln>
         </p:spPr>
@@ -16107,7 +16205,7 @@
       </p:cxnSp>
       <p:sp>
         <p:nvSpPr>
-          <p:cNvPr id="8" name="TextBox 7"/>
+          <p:cNvPr id="7" name="TextBox 6"/>
           <p:cNvSpPr txBox="1"/>
           <p:nvPr/>
         </p:nvSpPr>
@@ -16138,7 +16236,7 @@
             <a:r>
               <a:rPr sz="850" b="0">
                 <a:solidFill>
-                  <a:srgbClr val="CCEEE2"/>
+                  <a:srgbClr val="586C71"/>
                 </a:solidFill>
                 <a:latin typeface="Aptos"/>
               </a:rPr>
@@ -16149,7 +16247,7 @@
       </p:sp>
       <p:sp>
         <p:nvSpPr>
-          <p:cNvPr id="9" name="TextBox 8"/>
+          <p:cNvPr id="8" name="TextBox 7"/>
           <p:cNvSpPr txBox="1"/>
           <p:nvPr/>
         </p:nvSpPr>
@@ -16180,7 +16278,7 @@
             <a:r>
               <a:rPr sz="950" b="0">
                 <a:solidFill>
-                  <a:srgbClr val="CCEEE2"/>
+                  <a:srgbClr val="586C71"/>
                 </a:solidFill>
                 <a:latin typeface="Aptos"/>
               </a:rPr>
@@ -16191,14 +16289,148 @@
       </p:sp>
       <p:sp>
         <p:nvSpPr>
-          <p:cNvPr id="10" name="TextBox 9"/>
+          <p:cNvPr id="9" name="Rounded Rectangle 8"/>
+          <p:cNvSpPr/>
+          <p:nvPr/>
+        </p:nvSpPr>
+        <p:spPr>
+          <a:xfrm>
+            <a:off x="658368" y="1892807"/>
+            <a:ext cx="3246120" cy="3364992"/>
+          </a:xfrm>
+          <a:prstGeom prst="roundRect">
+            <a:avLst>
+              <a:gd name="adj" fmla="val 18000"/>
+            </a:avLst>
+          </a:prstGeom>
+          <a:solidFill>
+            <a:srgbClr val="FFFFFF"/>
+          </a:solidFill>
+          <a:ln w="10160">
+            <a:solidFill>
+              <a:srgbClr val="DBE6E2"/>
+            </a:solidFill>
+          </a:ln>
+        </p:spPr>
+        <p:style>
+          <a:lnRef idx="1">
+            <a:schemeClr val="accent1"/>
+          </a:lnRef>
+          <a:fillRef idx="3">
+            <a:schemeClr val="accent1"/>
+          </a:fillRef>
+          <a:effectRef idx="2">
+            <a:schemeClr val="accent1"/>
+          </a:effectRef>
+          <a:fontRef idx="minor">
+            <a:schemeClr val="lt1"/>
+          </a:fontRef>
+        </p:style>
+        <p:txBody>
+          <a:bodyPr rtlCol="0" anchor="ctr"/>
+          <a:lstStyle/>
+          <a:p>
+            <a:pPr algn="ctr"/>
+          </a:p>
+        </p:txBody>
+      </p:sp>
+      <p:sp>
+        <p:nvSpPr>
+          <p:cNvPr id="10" name="Rounded Rectangle 9"/>
+          <p:cNvSpPr/>
+          <p:nvPr/>
+        </p:nvSpPr>
+        <p:spPr>
+          <a:xfrm>
+            <a:off x="658368" y="2093976"/>
+            <a:ext cx="54864" cy="2962656"/>
+          </a:xfrm>
+          <a:prstGeom prst="roundRect">
+            <a:avLst>
+              <a:gd name="adj" fmla="val 18000"/>
+            </a:avLst>
+          </a:prstGeom>
+          <a:solidFill>
+            <a:srgbClr val="096752"/>
+          </a:solidFill>
+          <a:ln>
+            <a:noFill/>
+          </a:ln>
+        </p:spPr>
+        <p:style>
+          <a:lnRef idx="1">
+            <a:schemeClr val="accent1"/>
+          </a:lnRef>
+          <a:fillRef idx="3">
+            <a:schemeClr val="accent1"/>
+          </a:fillRef>
+          <a:effectRef idx="2">
+            <a:schemeClr val="accent1"/>
+          </a:effectRef>
+          <a:fontRef idx="minor">
+            <a:schemeClr val="lt1"/>
+          </a:fontRef>
+        </p:style>
+        <p:txBody>
+          <a:bodyPr rtlCol="0" anchor="ctr"/>
+          <a:lstStyle/>
+          <a:p>
+            <a:pPr algn="ctr"/>
+          </a:p>
+        </p:txBody>
+      </p:sp>
+      <p:sp>
+        <p:nvSpPr>
+          <p:cNvPr id="11" name="TextBox 10"/>
           <p:cNvSpPr txBox="1"/>
           <p:nvPr/>
         </p:nvSpPr>
         <p:spPr>
           <a:xfrm>
-            <a:off x="777240" y="1874519"/>
-            <a:ext cx="9738360" cy="1472184"/>
+            <a:off x="877824" y="2075688"/>
+            <a:ext cx="2825496" cy="475488"/>
+          </a:xfrm>
+          <a:prstGeom prst="rect">
+            <a:avLst/>
+          </a:prstGeom>
+          <a:noFill/>
+        </p:spPr>
+        <p:txBody>
+          <a:bodyPr wrap="square" lIns="27432" rIns="27432" tIns="27432" bIns="27432" anchor="ctr">
+            <a:spAutoFit/>
+          </a:bodyPr>
+          <a:lstStyle/>
+          <a:p>
+            <a:pPr algn="l">
+              <a:lnSpc>
+                <a:spcPct val="108000"/>
+              </a:lnSpc>
+              <a:spcAft>
+                <a:spcPts val="0"/>
+              </a:spcAft>
+            </a:pPr>
+            <a:r>
+              <a:rPr sz="1700" b="1">
+                <a:solidFill>
+                  <a:srgbClr val="1A2F37"/>
+                </a:solidFill>
+                <a:latin typeface="Aptos"/>
+              </a:rPr>
+              <a:t>Manajer Penjualan</a:t>
+            </a:r>
+          </a:p>
+        </p:txBody>
+      </p:sp>
+      <p:sp>
+        <p:nvSpPr>
+          <p:cNvPr id="12" name="TextBox 11"/>
+          <p:cNvSpPr txBox="1"/>
+          <p:nvPr/>
+        </p:nvSpPr>
+        <p:spPr>
+          <a:xfrm>
+            <a:off x="877824" y="2606039"/>
+            <a:ext cx="2807208" cy="2468880"/>
           </a:xfrm>
           <a:prstGeom prst="rect">
             <a:avLst/>
@@ -16213,53 +16445,236 @@
           <a:p>
             <a:pPr algn="l">
               <a:lnSpc>
-                <a:spcPct val="108000"/>
-              </a:lnSpc>
-              <a:spcAft>
-                <a:spcPts val="0"/>
-              </a:spcAft>
-            </a:pPr>
-            <a:r>
-              <a:rPr sz="3000" b="1">
-                <a:solidFill>
-                  <a:srgbClr val="FFFFFF"/>
-                </a:solidFill>
-                <a:latin typeface="Aptos"/>
-              </a:rPr>
-              <a:t>Google Sheet tetap menjadi titik awal.</a:t>
+                <a:spcPct val="120000"/>
+              </a:lnSpc>
+              <a:spcAft>
+                <a:spcPts val="0"/>
+              </a:spcAft>
+            </a:pPr>
+            <a:r>
+              <a:rPr sz="1450" b="0">
+                <a:solidFill>
+                  <a:srgbClr val="586C71"/>
+                </a:solidFill>
+                <a:latin typeface="Aptos"/>
+              </a:rPr>
+              <a:t>Unit yang dipilih admin:</a:t>
             </a:r>
           </a:p>
           <a:p>
             <a:pPr algn="l">
               <a:lnSpc>
-                <a:spcPct val="108000"/>
-              </a:lnSpc>
-              <a:spcAft>
-                <a:spcPts val="0"/>
-              </a:spcAft>
-            </a:pPr>
-            <a:r>
-              <a:rPr sz="3000" b="1">
-                <a:solidFill>
-                  <a:srgbClr val="FFFFFF"/>
-                </a:solidFill>
-                <a:latin typeface="Aptos"/>
-              </a:rPr>
-              <a:t>Kepercayaan dibangun melalui proses.</a:t>
-            </a:r>
-          </a:p>
-        </p:txBody>
-      </p:sp>
-      <p:sp>
-        <p:nvSpPr>
-          <p:cNvPr id="11" name="TextBox 10"/>
+                <a:spcPct val="120000"/>
+              </a:lnSpc>
+              <a:spcAft>
+                <a:spcPts val="0"/>
+              </a:spcAft>
+            </a:pPr>
+            <a:r>
+              <a:rPr sz="1450" b="0">
+                <a:solidFill>
+                  <a:srgbClr val="586C71"/>
+                </a:solidFill>
+                <a:latin typeface="Aptos"/>
+              </a:rPr>
+              <a:t>• Penjualan Malang</a:t>
+            </a:r>
+          </a:p>
+          <a:p>
+            <a:pPr algn="l">
+              <a:lnSpc>
+                <a:spcPct val="120000"/>
+              </a:lnSpc>
+              <a:spcAft>
+                <a:spcPts val="0"/>
+              </a:spcAft>
+            </a:pPr>
+            <a:r>
+              <a:rPr sz="1450" b="0">
+                <a:solidFill>
+                  <a:srgbClr val="586C71"/>
+                </a:solidFill>
+                <a:latin typeface="Aptos"/>
+              </a:rPr>
+              <a:t>• Penjualan Surabaya</a:t>
+            </a:r>
+          </a:p>
+          <a:p>
+            <a:pPr algn="l">
+              <a:lnSpc>
+                <a:spcPct val="120000"/>
+              </a:lnSpc>
+              <a:spcAft>
+                <a:spcPts val="0"/>
+              </a:spcAft>
+            </a:pPr>
+          </a:p>
+          <a:p>
+            <a:pPr algn="l">
+              <a:lnSpc>
+                <a:spcPct val="120000"/>
+              </a:lnSpc>
+              <a:spcAft>
+                <a:spcPts val="0"/>
+              </a:spcAft>
+            </a:pPr>
+            <a:r>
+              <a:rPr sz="1450" b="0">
+                <a:solidFill>
+                  <a:srgbClr val="586C71"/>
+                </a:solidFill>
+                <a:latin typeface="Aptos"/>
+              </a:rPr>
+              <a:t>Induk organisasi tidak otomatis membuka unit bawahan.</a:t>
+            </a:r>
+          </a:p>
+        </p:txBody>
+      </p:sp>
+      <p:sp>
+        <p:nvSpPr>
+          <p:cNvPr id="13" name="Chevron 12"/>
+          <p:cNvSpPr/>
+          <p:nvPr/>
+        </p:nvSpPr>
+        <p:spPr>
+          <a:xfrm>
+            <a:off x="4050791" y="3163824"/>
+            <a:ext cx="246888" cy="246888"/>
+          </a:xfrm>
+          <a:prstGeom prst="chevron">
+            <a:avLst/>
+          </a:prstGeom>
+          <a:solidFill>
+            <a:srgbClr val="11877A"/>
+          </a:solidFill>
+          <a:ln>
+            <a:noFill/>
+          </a:ln>
+        </p:spPr>
+        <p:style>
+          <a:lnRef idx="1">
+            <a:schemeClr val="accent1"/>
+          </a:lnRef>
+          <a:fillRef idx="3">
+            <a:schemeClr val="accent1"/>
+          </a:fillRef>
+          <a:effectRef idx="2">
+            <a:schemeClr val="accent1"/>
+          </a:effectRef>
+          <a:fontRef idx="minor">
+            <a:schemeClr val="lt1"/>
+          </a:fontRef>
+        </p:style>
+        <p:txBody>
+          <a:bodyPr rtlCol="0" anchor="ctr"/>
+          <a:lstStyle/>
+          <a:p>
+            <a:pPr algn="ctr"/>
+          </a:p>
+        </p:txBody>
+      </p:sp>
+      <p:sp>
+        <p:nvSpPr>
+          <p:cNvPr id="14" name="Rounded Rectangle 13"/>
+          <p:cNvSpPr/>
+          <p:nvPr/>
+        </p:nvSpPr>
+        <p:spPr>
+          <a:xfrm>
+            <a:off x="4507992" y="1892807"/>
+            <a:ext cx="3246120" cy="3364992"/>
+          </a:xfrm>
+          <a:prstGeom prst="roundRect">
+            <a:avLst>
+              <a:gd name="adj" fmla="val 18000"/>
+            </a:avLst>
+          </a:prstGeom>
+          <a:solidFill>
+            <a:srgbClr val="FFFFFF"/>
+          </a:solidFill>
+          <a:ln w="10160">
+            <a:solidFill>
+              <a:srgbClr val="DBE6E2"/>
+            </a:solidFill>
+          </a:ln>
+        </p:spPr>
+        <p:style>
+          <a:lnRef idx="1">
+            <a:schemeClr val="accent1"/>
+          </a:lnRef>
+          <a:fillRef idx="3">
+            <a:schemeClr val="accent1"/>
+          </a:fillRef>
+          <a:effectRef idx="2">
+            <a:schemeClr val="accent1"/>
+          </a:effectRef>
+          <a:fontRef idx="minor">
+            <a:schemeClr val="lt1"/>
+          </a:fontRef>
+        </p:style>
+        <p:txBody>
+          <a:bodyPr rtlCol="0" anchor="ctr"/>
+          <a:lstStyle/>
+          <a:p>
+            <a:pPr algn="ctr"/>
+          </a:p>
+        </p:txBody>
+      </p:sp>
+      <p:sp>
+        <p:nvSpPr>
+          <p:cNvPr id="15" name="Rounded Rectangle 14"/>
+          <p:cNvSpPr/>
+          <p:nvPr/>
+        </p:nvSpPr>
+        <p:spPr>
+          <a:xfrm>
+            <a:off x="4507992" y="2093976"/>
+            <a:ext cx="54864" cy="2962656"/>
+          </a:xfrm>
+          <a:prstGeom prst="roundRect">
+            <a:avLst>
+              <a:gd name="adj" fmla="val 18000"/>
+            </a:avLst>
+          </a:prstGeom>
+          <a:solidFill>
+            <a:srgbClr val="11877A"/>
+          </a:solidFill>
+          <a:ln>
+            <a:noFill/>
+          </a:ln>
+        </p:spPr>
+        <p:style>
+          <a:lnRef idx="1">
+            <a:schemeClr val="accent1"/>
+          </a:lnRef>
+          <a:fillRef idx="3">
+            <a:schemeClr val="accent1"/>
+          </a:fillRef>
+          <a:effectRef idx="2">
+            <a:schemeClr val="accent1"/>
+          </a:effectRef>
+          <a:fontRef idx="minor">
+            <a:schemeClr val="lt1"/>
+          </a:fontRef>
+        </p:style>
+        <p:txBody>
+          <a:bodyPr rtlCol="0" anchor="ctr"/>
+          <a:lstStyle/>
+          <a:p>
+            <a:pPr algn="ctr"/>
+          </a:p>
+        </p:txBody>
+      </p:sp>
+      <p:sp>
+        <p:nvSpPr>
+          <p:cNvPr id="16" name="TextBox 15"/>
           <p:cNvSpPr txBox="1"/>
           <p:nvPr/>
         </p:nvSpPr>
         <p:spPr>
           <a:xfrm>
-            <a:off x="832104" y="3895344"/>
-            <a:ext cx="10515600" cy="731520"/>
+            <a:off x="4727448" y="2075688"/>
+            <a:ext cx="2825496" cy="475488"/>
           </a:xfrm>
           <a:prstGeom prst="rect">
             <a:avLst/>
@@ -16281,27 +16696,242 @@
               </a:spcAft>
             </a:pPr>
             <a:r>
-              <a:rPr sz="2000" b="1">
-                <a:solidFill>
-                  <a:srgbClr val="CCEEE2"/>
-                </a:solidFill>
-                <a:latin typeface="Aptos"/>
-              </a:rPr>
-              <a:t>Daftarkan  →  Maknai  →  Validasi  →  Setujui  →  Gunakan</a:t>
-            </a:r>
-          </a:p>
-        </p:txBody>
-      </p:sp>
-      <p:sp>
-        <p:nvSpPr>
-          <p:cNvPr id="12" name="TextBox 11"/>
+              <a:rPr sz="1700" b="1">
+                <a:solidFill>
+                  <a:srgbClr val="1A2F37"/>
+                </a:solidFill>
+                <a:latin typeface="Aptos"/>
+              </a:rPr>
+              <a:t>Sumber Penjualan Malang</a:t>
+            </a:r>
+          </a:p>
+        </p:txBody>
+      </p:sp>
+      <p:sp>
+        <p:nvSpPr>
+          <p:cNvPr id="17" name="TextBox 16"/>
           <p:cNvSpPr txBox="1"/>
           <p:nvPr/>
         </p:nvSpPr>
         <p:spPr>
           <a:xfrm>
-            <a:off x="832104" y="5193792"/>
-            <a:ext cx="10241280" cy="576072"/>
+            <a:off x="4727448" y="2606039"/>
+            <a:ext cx="2807208" cy="2468880"/>
+          </a:xfrm>
+          <a:prstGeom prst="rect">
+            <a:avLst/>
+          </a:prstGeom>
+          <a:noFill/>
+        </p:spPr>
+        <p:txBody>
+          <a:bodyPr wrap="square" lIns="27432" rIns="27432" tIns="27432" bIns="27432" anchor="t">
+            <a:spAutoFit/>
+          </a:bodyPr>
+          <a:lstStyle/>
+          <a:p>
+            <a:pPr algn="l">
+              <a:lnSpc>
+                <a:spcPct val="120000"/>
+              </a:lnSpc>
+              <a:spcAft>
+                <a:spcPts val="0"/>
+              </a:spcAft>
+            </a:pPr>
+            <a:r>
+              <a:rPr sz="1450" b="0">
+                <a:solidFill>
+                  <a:srgbClr val="586C71"/>
+                </a:solidFill>
+                <a:latin typeface="Aptos"/>
+              </a:rPr>
+              <a:t>Metadata unit pemilik + domain + yurisdiksi</a:t>
+            </a:r>
+          </a:p>
+          <a:p>
+            <a:pPr algn="l">
+              <a:lnSpc>
+                <a:spcPct val="120000"/>
+              </a:lnSpc>
+              <a:spcAft>
+                <a:spcPts val="0"/>
+              </a:spcAft>
+            </a:pPr>
+            <a:r>
+              <a:rPr sz="1450" b="0">
+                <a:solidFill>
+                  <a:srgbClr val="586C71"/>
+                </a:solidFill>
+                <a:latin typeface="Aptos"/>
+              </a:rPr>
+              <a:t>Policy aktif menentukan aksi baca/query</a:t>
+            </a:r>
+          </a:p>
+          <a:p>
+            <a:pPr algn="l">
+              <a:lnSpc>
+                <a:spcPct val="120000"/>
+              </a:lnSpc>
+              <a:spcAft>
+                <a:spcPts val="0"/>
+              </a:spcAft>
+            </a:pPr>
+            <a:r>
+              <a:rPr sz="1450" b="0">
+                <a:solidFill>
+                  <a:srgbClr val="586C71"/>
+                </a:solidFill>
+                <a:latin typeface="Aptos"/>
+              </a:rPr>
+              <a:t>Penunjukan reviewer tidak membuka data.</a:t>
+            </a:r>
+          </a:p>
+        </p:txBody>
+      </p:sp>
+      <p:sp>
+        <p:nvSpPr>
+          <p:cNvPr id="18" name="Chevron 17"/>
+          <p:cNvSpPr/>
+          <p:nvPr/>
+        </p:nvSpPr>
+        <p:spPr>
+          <a:xfrm>
+            <a:off x="7882127" y="3163824"/>
+            <a:ext cx="246888" cy="246888"/>
+          </a:xfrm>
+          <a:prstGeom prst="chevron">
+            <a:avLst/>
+          </a:prstGeom>
+          <a:solidFill>
+            <a:srgbClr val="11877A"/>
+          </a:solidFill>
+          <a:ln>
+            <a:noFill/>
+          </a:ln>
+        </p:spPr>
+        <p:style>
+          <a:lnRef idx="1">
+            <a:schemeClr val="accent1"/>
+          </a:lnRef>
+          <a:fillRef idx="3">
+            <a:schemeClr val="accent1"/>
+          </a:fillRef>
+          <a:effectRef idx="2">
+            <a:schemeClr val="accent1"/>
+          </a:effectRef>
+          <a:fontRef idx="minor">
+            <a:schemeClr val="lt1"/>
+          </a:fontRef>
+        </p:style>
+        <p:txBody>
+          <a:bodyPr rtlCol="0" anchor="ctr"/>
+          <a:lstStyle/>
+          <a:p>
+            <a:pPr algn="ctr"/>
+          </a:p>
+        </p:txBody>
+      </p:sp>
+      <p:sp>
+        <p:nvSpPr>
+          <p:cNvPr id="19" name="Rounded Rectangle 18"/>
+          <p:cNvSpPr/>
+          <p:nvPr/>
+        </p:nvSpPr>
+        <p:spPr>
+          <a:xfrm>
+            <a:off x="8339327" y="1892807"/>
+            <a:ext cx="3191256" cy="3364992"/>
+          </a:xfrm>
+          <a:prstGeom prst="roundRect">
+            <a:avLst>
+              <a:gd name="adj" fmla="val 18000"/>
+            </a:avLst>
+          </a:prstGeom>
+          <a:solidFill>
+            <a:srgbClr val="FFFFFF"/>
+          </a:solidFill>
+          <a:ln w="10160">
+            <a:solidFill>
+              <a:srgbClr val="DBE6E2"/>
+            </a:solidFill>
+          </a:ln>
+        </p:spPr>
+        <p:style>
+          <a:lnRef idx="1">
+            <a:schemeClr val="accent1"/>
+          </a:lnRef>
+          <a:fillRef idx="3">
+            <a:schemeClr val="accent1"/>
+          </a:fillRef>
+          <a:effectRef idx="2">
+            <a:schemeClr val="accent1"/>
+          </a:effectRef>
+          <a:fontRef idx="minor">
+            <a:schemeClr val="lt1"/>
+          </a:fontRef>
+        </p:style>
+        <p:txBody>
+          <a:bodyPr rtlCol="0" anchor="ctr"/>
+          <a:lstStyle/>
+          <a:p>
+            <a:pPr algn="ctr"/>
+          </a:p>
+        </p:txBody>
+      </p:sp>
+      <p:sp>
+        <p:nvSpPr>
+          <p:cNvPr id="20" name="Rounded Rectangle 19"/>
+          <p:cNvSpPr/>
+          <p:nvPr/>
+        </p:nvSpPr>
+        <p:spPr>
+          <a:xfrm>
+            <a:off x="8339327" y="2093976"/>
+            <a:ext cx="54864" cy="2962656"/>
+          </a:xfrm>
+          <a:prstGeom prst="roundRect">
+            <a:avLst>
+              <a:gd name="adj" fmla="val 18000"/>
+            </a:avLst>
+          </a:prstGeom>
+          <a:solidFill>
+            <a:srgbClr val="CF8B3A"/>
+          </a:solidFill>
+          <a:ln>
+            <a:noFill/>
+          </a:ln>
+        </p:spPr>
+        <p:style>
+          <a:lnRef idx="1">
+            <a:schemeClr val="accent1"/>
+          </a:lnRef>
+          <a:fillRef idx="3">
+            <a:schemeClr val="accent1"/>
+          </a:fillRef>
+          <a:effectRef idx="2">
+            <a:schemeClr val="accent1"/>
+          </a:effectRef>
+          <a:fontRef idx="minor">
+            <a:schemeClr val="lt1"/>
+          </a:fontRef>
+        </p:style>
+        <p:txBody>
+          <a:bodyPr rtlCol="0" anchor="ctr"/>
+          <a:lstStyle/>
+          <a:p>
+            <a:pPr algn="ctr"/>
+          </a:p>
+        </p:txBody>
+      </p:sp>
+      <p:sp>
+        <p:nvSpPr>
+          <p:cNvPr id="21" name="TextBox 20"/>
+          <p:cNvSpPr txBox="1"/>
+          <p:nvPr/>
+        </p:nvSpPr>
+        <p:spPr>
+          <a:xfrm>
+            <a:off x="8558784" y="2075688"/>
+            <a:ext cx="2770632" cy="475488"/>
           </a:xfrm>
           <a:prstGeom prst="rect">
             <a:avLst/>
@@ -16323,18 +16953,150 @@
               </a:spcAft>
             </a:pPr>
             <a:r>
-              <a:rPr sz="1000" b="0">
-                <a:solidFill>
-                  <a:srgbClr val="CCEEE2"/>
-                </a:solidFill>
-                <a:latin typeface="Aptos"/>
-              </a:rPr>
-              <a:t>Sumber: USER_GUIDE_END_TO_END.md · ACCESS_JURISDICTION_BE16.md ·</a:t>
-            </a:r>
-          </a:p>
+              <a:rPr sz="1700" b="1">
+                <a:solidFill>
+                  <a:srgbClr val="1A2F37"/>
+                </a:solidFill>
+                <a:latin typeface="Aptos"/>
+              </a:rPr>
+              <a:t>Reviewer ditunjuk</a:t>
+            </a:r>
+          </a:p>
+        </p:txBody>
+      </p:sp>
+      <p:sp>
+        <p:nvSpPr>
+          <p:cNvPr id="22" name="TextBox 21"/>
+          <p:cNvSpPr txBox="1"/>
+          <p:nvPr/>
+        </p:nvSpPr>
+        <p:spPr>
+          <a:xfrm>
+            <a:off x="8558784" y="2606039"/>
+            <a:ext cx="2752344" cy="2468880"/>
+          </a:xfrm>
+          <a:prstGeom prst="rect">
+            <a:avLst/>
+          </a:prstGeom>
+          <a:noFill/>
+        </p:spPr>
+        <p:txBody>
+          <a:bodyPr wrap="square" lIns="27432" rIns="27432" tIns="27432" bIns="27432" anchor="t">
+            <a:spAutoFit/>
+          </a:bodyPr>
+          <a:lstStyle/>
           <a:p>
             <a:pPr algn="l">
               <a:lnSpc>
+                <a:spcPct val="120000"/>
+              </a:lnSpc>
+              <a:spcAft>
+                <a:spcPts val="0"/>
+              </a:spcAft>
+            </a:pPr>
+            <a:r>
+              <a:rPr sz="1450" b="0">
+                <a:solidFill>
+                  <a:srgbClr val="586C71"/>
+                </a:solidFill>
+                <a:latin typeface="Aptos"/>
+              </a:rPr>
+              <a:t>Metadata: Manajer A</a:t>
+            </a:r>
+          </a:p>
+          <a:p>
+            <a:pPr algn="l">
+              <a:lnSpc>
+                <a:spcPct val="120000"/>
+              </a:lnSpc>
+              <a:spcAft>
+                <a:spcPts val="0"/>
+              </a:spcAft>
+            </a:pPr>
+            <a:r>
+              <a:rPr sz="1450" b="0">
+                <a:solidFill>
+                  <a:srgbClr val="586C71"/>
+                </a:solidFill>
+                <a:latin typeface="Aptos"/>
+              </a:rPr>
+              <a:t>Konfigurasi: Manajer A</a:t>
+            </a:r>
+          </a:p>
+          <a:p>
+            <a:pPr algn="l">
+              <a:lnSpc>
+                <a:spcPct val="120000"/>
+              </a:lnSpc>
+              <a:spcAft>
+                <a:spcPts val="0"/>
+              </a:spcAft>
+            </a:pPr>
+            <a:r>
+              <a:rPr sz="1450" b="0">
+                <a:solidFill>
+                  <a:srgbClr val="586C71"/>
+                </a:solidFill>
+                <a:latin typeface="Aptos"/>
+              </a:rPr>
+              <a:t>Batch import: Manajer B</a:t>
+            </a:r>
+          </a:p>
+          <a:p>
+            <a:pPr algn="l">
+              <a:lnSpc>
+                <a:spcPct val="120000"/>
+              </a:lnSpc>
+              <a:spcAft>
+                <a:spcPts val="0"/>
+              </a:spcAft>
+            </a:pPr>
+          </a:p>
+          <a:p>
+            <a:pPr algn="l">
+              <a:lnSpc>
+                <a:spcPct val="120000"/>
+              </a:lnSpc>
+              <a:spcAft>
+                <a:spcPts val="0"/>
+              </a:spcAft>
+            </a:pPr>
+            <a:r>
+              <a:rPr sz="1450" b="0">
+                <a:solidFill>
+                  <a:srgbClr val="586C71"/>
+                </a:solidFill>
+                <a:latin typeface="Aptos"/>
+              </a:rPr>
+              <a:t>Reviewer berbeda dari pengaju.</a:t>
+            </a:r>
+          </a:p>
+        </p:txBody>
+      </p:sp>
+      <p:sp>
+        <p:nvSpPr>
+          <p:cNvPr id="23" name="TextBox 22"/>
+          <p:cNvSpPr txBox="1"/>
+          <p:nvPr/>
+        </p:nvSpPr>
+        <p:spPr>
+          <a:xfrm>
+            <a:off x="768096" y="5596128"/>
+            <a:ext cx="10789920" cy="438912"/>
+          </a:xfrm>
+          <a:prstGeom prst="rect">
+            <a:avLst/>
+          </a:prstGeom>
+          <a:noFill/>
+        </p:spPr>
+        <p:txBody>
+          <a:bodyPr wrap="square" lIns="27432" rIns="27432" tIns="27432" bIns="27432" anchor="ctr">
+            <a:spAutoFit/>
+          </a:bodyPr>
+          <a:lstStyle/>
+          <a:p>
+            <a:pPr algn="ctr">
+              <a:lnSpc>
                 <a:spcPct val="108000"/>
               </a:lnSpc>
               <a:spcAft>
@@ -16342,13 +17104,13 @@
               </a:spcAft>
             </a:pPr>
             <a:r>
-              <a:rPr sz="1000" b="0">
-                <a:solidFill>
-                  <a:srgbClr val="CCEEE2"/>
-                </a:solidFill>
-                <a:latin typeface="Aptos"/>
-              </a:rPr>
-              <a:t>MASTER_DATA_DAN_VALIDASI_IMPORT.md · CONTOH_ISIAN_APLIKASI.md · AI_USER_HELP.md</a:t>
+              <a:rPr sz="1500" b="1">
+                <a:solidFill>
+                  <a:srgbClr val="096752"/>
+                </a:solidFill>
+                <a:latin typeface="Aptos"/>
+              </a:rPr>
+              <a:t>Akses = unit eksplisit + policy  |  Approval = reviewer aktif + jenis keputusan + pemisahan tugas</a:t>
             </a:r>
           </a:p>
         </p:txBody>
@@ -17446,6 +18208,1726 @@
                 <a:latin typeface="Aptos"/>
               </a:rPr>
               <a:t>Kebutuhan utama: satu jalur yang menambah konteks, kualitas, persetujuan, dan akses sebelum data dipakai.</a:t>
+            </a:r>
+          </a:p>
+        </p:txBody>
+      </p:sp>
+    </p:spTree>
+  </p:cSld>
+  <p:clrMapOvr>
+    <a:masterClrMapping/>
+  </p:clrMapOvr>
+</p:sld>
+</file>
+
+<file path=ppt/slides/slide20.xml><?xml version="1.0" encoding="utf-8"?>
+<p:sld xmlns:a="http://schemas.openxmlformats.org/drawingml/2006/main" xmlns:p="http://schemas.openxmlformats.org/presentationml/2006/main" xmlns:r="http://schemas.openxmlformats.org/officeDocument/2006/relationships">
+  <p:cSld>
+    <p:spTree>
+      <p:nvGrpSpPr>
+        <p:cNvPr id="1" name=""/>
+        <p:cNvGrpSpPr/>
+        <p:nvPr/>
+      </p:nvGrpSpPr>
+      <p:grpSpPr/>
+      <p:sp>
+        <p:nvSpPr>
+          <p:cNvPr id="2" name="Rectangle 1"/>
+          <p:cNvSpPr/>
+          <p:nvPr/>
+        </p:nvSpPr>
+        <p:spPr>
+          <a:xfrm>
+            <a:off x="0" y="0"/>
+            <a:ext cx="12191695" cy="6858000"/>
+          </a:xfrm>
+          <a:prstGeom prst="rect">
+            <a:avLst/>
+          </a:prstGeom>
+          <a:solidFill>
+            <a:srgbClr val="F7F9F5"/>
+          </a:solidFill>
+          <a:ln>
+            <a:noFill/>
+          </a:ln>
+        </p:spPr>
+        <p:style>
+          <a:lnRef idx="1">
+            <a:schemeClr val="accent1"/>
+          </a:lnRef>
+          <a:fillRef idx="3">
+            <a:schemeClr val="accent1"/>
+          </a:fillRef>
+          <a:effectRef idx="2">
+            <a:schemeClr val="accent1"/>
+          </a:effectRef>
+          <a:fontRef idx="minor">
+            <a:schemeClr val="lt1"/>
+          </a:fontRef>
+        </p:style>
+        <p:txBody>
+          <a:bodyPr rtlCol="0" anchor="ctr"/>
+          <a:lstStyle/>
+          <a:p>
+            <a:pPr algn="ctr"/>
+          </a:p>
+        </p:txBody>
+      </p:sp>
+      <p:sp>
+        <p:nvSpPr>
+          <p:cNvPr id="3" name="TextBox 2"/>
+          <p:cNvSpPr txBox="1"/>
+          <p:nvPr/>
+        </p:nvSpPr>
+        <p:spPr>
+          <a:xfrm>
+            <a:off x="658368" y="338328"/>
+            <a:ext cx="9601200" cy="256032"/>
+          </a:xfrm>
+          <a:prstGeom prst="rect">
+            <a:avLst/>
+          </a:prstGeom>
+          <a:noFill/>
+        </p:spPr>
+        <p:txBody>
+          <a:bodyPr wrap="square" lIns="27432" rIns="27432" tIns="27432" bIns="27432" anchor="ctr">
+            <a:spAutoFit/>
+          </a:bodyPr>
+          <a:lstStyle/>
+          <a:p>
+            <a:pPr algn="l">
+              <a:lnSpc>
+                <a:spcPct val="108000"/>
+              </a:lnSpc>
+              <a:spcAft>
+                <a:spcPts val="0"/>
+              </a:spcAft>
+            </a:pPr>
+            <a:r>
+              <a:rPr sz="1050" b="1">
+                <a:solidFill>
+                  <a:srgbClr val="096752"/>
+                </a:solidFill>
+                <a:latin typeface="Aptos"/>
+              </a:rPr>
+              <a:t>TATA KELOLA · GATE RILIS</a:t>
+            </a:r>
+          </a:p>
+        </p:txBody>
+      </p:sp>
+      <p:sp>
+        <p:nvSpPr>
+          <p:cNvPr id="4" name="TextBox 3"/>
+          <p:cNvSpPr txBox="1"/>
+          <p:nvPr/>
+        </p:nvSpPr>
+        <p:spPr>
+          <a:xfrm>
+            <a:off x="658368" y="713232"/>
+            <a:ext cx="10835640" cy="621792"/>
+          </a:xfrm>
+          <a:prstGeom prst="rect">
+            <a:avLst/>
+          </a:prstGeom>
+          <a:noFill/>
+        </p:spPr>
+        <p:txBody>
+          <a:bodyPr wrap="square" lIns="27432" rIns="27432" tIns="27432" bIns="27432" anchor="ctr">
+            <a:spAutoFit/>
+          </a:bodyPr>
+          <a:lstStyle/>
+          <a:p>
+            <a:pPr algn="l">
+              <a:lnSpc>
+                <a:spcPct val="108000"/>
+              </a:lnSpc>
+              <a:spcAft>
+                <a:spcPts val="0"/>
+              </a:spcAft>
+            </a:pPr>
+            <a:r>
+              <a:rPr sz="2800" b="1">
+                <a:solidFill>
+                  <a:srgbClr val="1A2F37"/>
+                </a:solidFill>
+                <a:latin typeface="Aptos"/>
+              </a:rPr>
+              <a:t>Persetujuan sebelum data tayang</a:t>
+            </a:r>
+          </a:p>
+        </p:txBody>
+      </p:sp>
+      <p:sp>
+        <p:nvSpPr>
+          <p:cNvPr id="5" name="TextBox 4"/>
+          <p:cNvSpPr txBox="1"/>
+          <p:nvPr/>
+        </p:nvSpPr>
+        <p:spPr>
+          <a:xfrm>
+            <a:off x="685800" y="1362456"/>
+            <a:ext cx="10744200" cy="438912"/>
+          </a:xfrm>
+          <a:prstGeom prst="rect">
+            <a:avLst/>
+          </a:prstGeom>
+          <a:noFill/>
+        </p:spPr>
+        <p:txBody>
+          <a:bodyPr wrap="square" lIns="27432" rIns="27432" tIns="27432" bIns="27432" anchor="ctr">
+            <a:spAutoFit/>
+          </a:bodyPr>
+          <a:lstStyle/>
+          <a:p>
+            <a:pPr algn="l">
+              <a:lnSpc>
+                <a:spcPct val="108000"/>
+              </a:lnSpc>
+              <a:spcAft>
+                <a:spcPts val="0"/>
+              </a:spcAft>
+            </a:pPr>
+            <a:r>
+              <a:rPr sz="1300" b="0">
+                <a:solidFill>
+                  <a:srgbClr val="586C71"/>
+                </a:solidFill>
+                <a:latin typeface="Aptos"/>
+              </a:rPr>
+              <a:t>Contoh sumber gabungan: IT dan semua unit terkait menyetujui versi konfigurasi yang sama.</a:t>
+            </a:r>
+          </a:p>
+        </p:txBody>
+      </p:sp>
+      <p:cxnSp>
+        <p:nvCxnSpPr>
+          <p:cNvPr id="6" name="Connector 5"/>
+          <p:cNvCxnSpPr/>
+          <p:nvPr/>
+        </p:nvCxnSpPr>
+        <p:spPr>
+          <a:xfrm>
+            <a:off x="676656" y="6492240"/>
+            <a:ext cx="10799064" cy="0"/>
+          </a:xfrm>
+          <a:prstGeom prst="line">
+            <a:avLst/>
+          </a:prstGeom>
+          <a:ln w="16510">
+            <a:solidFill>
+              <a:srgbClr val="DBE6E2"/>
+            </a:solidFill>
+          </a:ln>
+        </p:spPr>
+        <p:style>
+          <a:lnRef idx="2">
+            <a:schemeClr val="accent1"/>
+          </a:lnRef>
+          <a:fillRef idx="0">
+            <a:schemeClr val="accent1"/>
+          </a:fillRef>
+          <a:effectRef idx="1">
+            <a:schemeClr val="accent1"/>
+          </a:effectRef>
+          <a:fontRef idx="minor">
+            <a:schemeClr val="tx1"/>
+          </a:fontRef>
+        </p:style>
+      </p:cxnSp>
+      <p:sp>
+        <p:nvSpPr>
+          <p:cNvPr id="7" name="TextBox 6"/>
+          <p:cNvSpPr txBox="1"/>
+          <p:nvPr/>
+        </p:nvSpPr>
+        <p:spPr>
+          <a:xfrm>
+            <a:off x="676656" y="6537960"/>
+            <a:ext cx="7132320" cy="164592"/>
+          </a:xfrm>
+          <a:prstGeom prst="rect">
+            <a:avLst/>
+          </a:prstGeom>
+          <a:noFill/>
+        </p:spPr>
+        <p:txBody>
+          <a:bodyPr wrap="square" lIns="27432" rIns="27432" tIns="27432" bIns="27432" anchor="ctr">
+            <a:spAutoFit/>
+          </a:bodyPr>
+          <a:lstStyle/>
+          <a:p>
+            <a:pPr algn="l">
+              <a:lnSpc>
+                <a:spcPct val="108000"/>
+              </a:lnSpc>
+              <a:spcAft>
+                <a:spcPts val="0"/>
+              </a:spcAft>
+            </a:pPr>
+            <a:r>
+              <a:rPr sz="850" b="0">
+                <a:solidFill>
+                  <a:srgbClr val="586C71"/>
+                </a:solidFill>
+                <a:latin typeface="Aptos"/>
+              </a:rPr>
+              <a:t>GOOGLE SHEET AI  ·  TINJAUAN APLIKASI</a:t>
+            </a:r>
+          </a:p>
+        </p:txBody>
+      </p:sp>
+      <p:sp>
+        <p:nvSpPr>
+          <p:cNvPr id="8" name="TextBox 7"/>
+          <p:cNvSpPr txBox="1"/>
+          <p:nvPr/>
+        </p:nvSpPr>
+        <p:spPr>
+          <a:xfrm>
+            <a:off x="10972800" y="6519672"/>
+            <a:ext cx="502920" cy="192024"/>
+          </a:xfrm>
+          <a:prstGeom prst="rect">
+            <a:avLst/>
+          </a:prstGeom>
+          <a:noFill/>
+        </p:spPr>
+        <p:txBody>
+          <a:bodyPr wrap="square" lIns="27432" rIns="27432" tIns="27432" bIns="27432" anchor="ctr">
+            <a:spAutoFit/>
+          </a:bodyPr>
+          <a:lstStyle/>
+          <a:p>
+            <a:pPr algn="r">
+              <a:lnSpc>
+                <a:spcPct val="108000"/>
+              </a:lnSpc>
+              <a:spcAft>
+                <a:spcPts val="0"/>
+              </a:spcAft>
+            </a:pPr>
+            <a:r>
+              <a:rPr sz="950" b="0">
+                <a:solidFill>
+                  <a:srgbClr val="586C71"/>
+                </a:solidFill>
+                <a:latin typeface="Aptos"/>
+              </a:rPr>
+              <a:t>20</a:t>
+            </a:r>
+          </a:p>
+        </p:txBody>
+      </p:sp>
+      <p:sp>
+        <p:nvSpPr>
+          <p:cNvPr id="9" name="Rounded Rectangle 8"/>
+          <p:cNvSpPr/>
+          <p:nvPr/>
+        </p:nvSpPr>
+        <p:spPr>
+          <a:xfrm>
+            <a:off x="859536" y="1993392"/>
+            <a:ext cx="10497312" cy="557784"/>
+          </a:xfrm>
+          <a:prstGeom prst="roundRect">
+            <a:avLst>
+              <a:gd name="adj" fmla="val 18000"/>
+            </a:avLst>
+          </a:prstGeom>
+          <a:solidFill>
+            <a:srgbClr val="0C1C29"/>
+          </a:solidFill>
+          <a:ln>
+            <a:noFill/>
+          </a:ln>
+        </p:spPr>
+        <p:style>
+          <a:lnRef idx="1">
+            <a:schemeClr val="accent1"/>
+          </a:lnRef>
+          <a:fillRef idx="3">
+            <a:schemeClr val="accent1"/>
+          </a:fillRef>
+          <a:effectRef idx="2">
+            <a:schemeClr val="accent1"/>
+          </a:effectRef>
+          <a:fontRef idx="minor">
+            <a:schemeClr val="lt1"/>
+          </a:fontRef>
+        </p:style>
+        <p:txBody>
+          <a:bodyPr rtlCol="0" anchor="ctr"/>
+          <a:lstStyle/>
+          <a:p>
+            <a:pPr algn="ctr"/>
+          </a:p>
+        </p:txBody>
+      </p:sp>
+      <p:sp>
+        <p:nvSpPr>
+          <p:cNvPr id="10" name="TextBox 9"/>
+          <p:cNvSpPr txBox="1"/>
+          <p:nvPr/>
+        </p:nvSpPr>
+        <p:spPr>
+          <a:xfrm>
+            <a:off x="1124712" y="2103120"/>
+            <a:ext cx="9930384" cy="338328"/>
+          </a:xfrm>
+          <a:prstGeom prst="rect">
+            <a:avLst/>
+          </a:prstGeom>
+          <a:noFill/>
+        </p:spPr>
+        <p:txBody>
+          <a:bodyPr wrap="square" lIns="27432" rIns="27432" tIns="27432" bIns="27432" anchor="ctr">
+            <a:spAutoFit/>
+          </a:bodyPr>
+          <a:lstStyle/>
+          <a:p>
+            <a:pPr algn="ctr">
+              <a:lnSpc>
+                <a:spcPct val="108000"/>
+              </a:lnSpc>
+              <a:spcAft>
+                <a:spcPts val="0"/>
+              </a:spcAft>
+            </a:pPr>
+            <a:r>
+              <a:rPr sz="1700" b="1">
+                <a:solidFill>
+                  <a:srgbClr val="FFFFFF"/>
+                </a:solidFill>
+                <a:latin typeface="Aptos"/>
+              </a:rPr>
+              <a:t>Konfigurasi ETL versi 2 approved dan siap diperiksa</a:t>
+            </a:r>
+          </a:p>
+        </p:txBody>
+      </p:sp>
+      <p:sp>
+        <p:nvSpPr>
+          <p:cNvPr id="11" name="Rounded Rectangle 10"/>
+          <p:cNvSpPr/>
+          <p:nvPr/>
+        </p:nvSpPr>
+        <p:spPr>
+          <a:xfrm>
+            <a:off x="731520" y="2688336"/>
+            <a:ext cx="3218688" cy="1993392"/>
+          </a:xfrm>
+          <a:prstGeom prst="roundRect">
+            <a:avLst>
+              <a:gd name="adj" fmla="val 18000"/>
+            </a:avLst>
+          </a:prstGeom>
+          <a:solidFill>
+            <a:srgbClr val="FFFFFF"/>
+          </a:solidFill>
+          <a:ln w="10160">
+            <a:solidFill>
+              <a:srgbClr val="DBE6E2"/>
+            </a:solidFill>
+          </a:ln>
+        </p:spPr>
+        <p:style>
+          <a:lnRef idx="1">
+            <a:schemeClr val="accent1"/>
+          </a:lnRef>
+          <a:fillRef idx="3">
+            <a:schemeClr val="accent1"/>
+          </a:fillRef>
+          <a:effectRef idx="2">
+            <a:schemeClr val="accent1"/>
+          </a:effectRef>
+          <a:fontRef idx="minor">
+            <a:schemeClr val="lt1"/>
+          </a:fontRef>
+        </p:style>
+        <p:txBody>
+          <a:bodyPr rtlCol="0" anchor="ctr"/>
+          <a:lstStyle/>
+          <a:p>
+            <a:pPr algn="ctr"/>
+          </a:p>
+        </p:txBody>
+      </p:sp>
+      <p:sp>
+        <p:nvSpPr>
+          <p:cNvPr id="12" name="Rounded Rectangle 11"/>
+          <p:cNvSpPr/>
+          <p:nvPr/>
+        </p:nvSpPr>
+        <p:spPr>
+          <a:xfrm>
+            <a:off x="731520" y="2889504"/>
+            <a:ext cx="54864" cy="1591056"/>
+          </a:xfrm>
+          <a:prstGeom prst="roundRect">
+            <a:avLst>
+              <a:gd name="adj" fmla="val 18000"/>
+            </a:avLst>
+          </a:prstGeom>
+          <a:solidFill>
+            <a:srgbClr val="096752"/>
+          </a:solidFill>
+          <a:ln>
+            <a:noFill/>
+          </a:ln>
+        </p:spPr>
+        <p:style>
+          <a:lnRef idx="1">
+            <a:schemeClr val="accent1"/>
+          </a:lnRef>
+          <a:fillRef idx="3">
+            <a:schemeClr val="accent1"/>
+          </a:fillRef>
+          <a:effectRef idx="2">
+            <a:schemeClr val="accent1"/>
+          </a:effectRef>
+          <a:fontRef idx="minor">
+            <a:schemeClr val="lt1"/>
+          </a:fontRef>
+        </p:style>
+        <p:txBody>
+          <a:bodyPr rtlCol="0" anchor="ctr"/>
+          <a:lstStyle/>
+          <a:p>
+            <a:pPr algn="ctr"/>
+          </a:p>
+        </p:txBody>
+      </p:sp>
+      <p:sp>
+        <p:nvSpPr>
+          <p:cNvPr id="13" name="TextBox 12"/>
+          <p:cNvSpPr txBox="1"/>
+          <p:nvPr/>
+        </p:nvSpPr>
+        <p:spPr>
+          <a:xfrm>
+            <a:off x="950976" y="2871216"/>
+            <a:ext cx="2798064" cy="475488"/>
+          </a:xfrm>
+          <a:prstGeom prst="rect">
+            <a:avLst/>
+          </a:prstGeom>
+          <a:noFill/>
+        </p:spPr>
+        <p:txBody>
+          <a:bodyPr wrap="square" lIns="27432" rIns="27432" tIns="27432" bIns="27432" anchor="ctr">
+            <a:spAutoFit/>
+          </a:bodyPr>
+          <a:lstStyle/>
+          <a:p>
+            <a:pPr algn="l">
+              <a:lnSpc>
+                <a:spcPct val="108000"/>
+              </a:lnSpc>
+              <a:spcAft>
+                <a:spcPts val="0"/>
+              </a:spcAft>
+            </a:pPr>
+            <a:r>
+              <a:rPr sz="1700" b="1">
+                <a:solidFill>
+                  <a:srgbClr val="1A2F37"/>
+                </a:solidFill>
+                <a:latin typeface="Aptos"/>
+              </a:rPr>
+              <a:t>IT · teknis</a:t>
+            </a:r>
+          </a:p>
+        </p:txBody>
+      </p:sp>
+      <p:sp>
+        <p:nvSpPr>
+          <p:cNvPr id="14" name="TextBox 13"/>
+          <p:cNvSpPr txBox="1"/>
+          <p:nvPr/>
+        </p:nvSpPr>
+        <p:spPr>
+          <a:xfrm>
+            <a:off x="950976" y="3401568"/>
+            <a:ext cx="2779776" cy="1097280"/>
+          </a:xfrm>
+          <a:prstGeom prst="rect">
+            <a:avLst/>
+          </a:prstGeom>
+          <a:noFill/>
+        </p:spPr>
+        <p:txBody>
+          <a:bodyPr wrap="square" lIns="27432" rIns="27432" tIns="27432" bIns="27432" anchor="t">
+            <a:spAutoFit/>
+          </a:bodyPr>
+          <a:lstStyle/>
+          <a:p>
+            <a:pPr algn="l">
+              <a:lnSpc>
+                <a:spcPct val="120000"/>
+              </a:lnSpc>
+              <a:spcAft>
+                <a:spcPts val="0"/>
+              </a:spcAft>
+            </a:pPr>
+            <a:r>
+              <a:rPr sz="1400" b="0">
+                <a:solidFill>
+                  <a:srgbClr val="586C71"/>
+                </a:solidFill>
+                <a:latin typeface="Aptos"/>
+              </a:rPr>
+              <a:t>Skema, DQ, keamanan,</a:t>
+            </a:r>
+          </a:p>
+          <a:p>
+            <a:pPr algn="l">
+              <a:lnSpc>
+                <a:spcPct val="120000"/>
+              </a:lnSpc>
+              <a:spcAft>
+                <a:spcPts val="0"/>
+              </a:spcAft>
+            </a:pPr>
+            <a:r>
+              <a:rPr sz="1400" b="0">
+                <a:solidFill>
+                  <a:srgbClr val="586C71"/>
+                </a:solidFill>
+                <a:latin typeface="Aptos"/>
+              </a:rPr>
+              <a:t>hasil dry-run</a:t>
+            </a:r>
+          </a:p>
+          <a:p>
+            <a:pPr algn="l">
+              <a:lnSpc>
+                <a:spcPct val="120000"/>
+              </a:lnSpc>
+              <a:spcAft>
+                <a:spcPts val="0"/>
+              </a:spcAft>
+            </a:pPr>
+            <a:r>
+              <a:rPr sz="1400" b="0">
+                <a:solidFill>
+                  <a:srgbClr val="586C71"/>
+                </a:solidFill>
+                <a:latin typeface="Aptos"/>
+              </a:rPr>
+              <a:t>Pemeriksa: approver.it</a:t>
+            </a:r>
+          </a:p>
+        </p:txBody>
+      </p:sp>
+      <p:sp>
+        <p:nvSpPr>
+          <p:cNvPr id="15" name="Rounded Rectangle 14"/>
+          <p:cNvSpPr/>
+          <p:nvPr/>
+        </p:nvSpPr>
+        <p:spPr>
+          <a:xfrm>
+            <a:off x="4480560" y="2688336"/>
+            <a:ext cx="3218688" cy="1993392"/>
+          </a:xfrm>
+          <a:prstGeom prst="roundRect">
+            <a:avLst>
+              <a:gd name="adj" fmla="val 18000"/>
+            </a:avLst>
+          </a:prstGeom>
+          <a:solidFill>
+            <a:srgbClr val="FFFFFF"/>
+          </a:solidFill>
+          <a:ln w="10160">
+            <a:solidFill>
+              <a:srgbClr val="DBE6E2"/>
+            </a:solidFill>
+          </a:ln>
+        </p:spPr>
+        <p:style>
+          <a:lnRef idx="1">
+            <a:schemeClr val="accent1"/>
+          </a:lnRef>
+          <a:fillRef idx="3">
+            <a:schemeClr val="accent1"/>
+          </a:fillRef>
+          <a:effectRef idx="2">
+            <a:schemeClr val="accent1"/>
+          </a:effectRef>
+          <a:fontRef idx="minor">
+            <a:schemeClr val="lt1"/>
+          </a:fontRef>
+        </p:style>
+        <p:txBody>
+          <a:bodyPr rtlCol="0" anchor="ctr"/>
+          <a:lstStyle/>
+          <a:p>
+            <a:pPr algn="ctr"/>
+          </a:p>
+        </p:txBody>
+      </p:sp>
+      <p:sp>
+        <p:nvSpPr>
+          <p:cNvPr id="16" name="Rounded Rectangle 15"/>
+          <p:cNvSpPr/>
+          <p:nvPr/>
+        </p:nvSpPr>
+        <p:spPr>
+          <a:xfrm>
+            <a:off x="4480560" y="2889504"/>
+            <a:ext cx="54864" cy="1591056"/>
+          </a:xfrm>
+          <a:prstGeom prst="roundRect">
+            <a:avLst>
+              <a:gd name="adj" fmla="val 18000"/>
+            </a:avLst>
+          </a:prstGeom>
+          <a:solidFill>
+            <a:srgbClr val="11877A"/>
+          </a:solidFill>
+          <a:ln>
+            <a:noFill/>
+          </a:ln>
+        </p:spPr>
+        <p:style>
+          <a:lnRef idx="1">
+            <a:schemeClr val="accent1"/>
+          </a:lnRef>
+          <a:fillRef idx="3">
+            <a:schemeClr val="accent1"/>
+          </a:fillRef>
+          <a:effectRef idx="2">
+            <a:schemeClr val="accent1"/>
+          </a:effectRef>
+          <a:fontRef idx="minor">
+            <a:schemeClr val="lt1"/>
+          </a:fontRef>
+        </p:style>
+        <p:txBody>
+          <a:bodyPr rtlCol="0" anchor="ctr"/>
+          <a:lstStyle/>
+          <a:p>
+            <a:pPr algn="ctr"/>
+          </a:p>
+        </p:txBody>
+      </p:sp>
+      <p:sp>
+        <p:nvSpPr>
+          <p:cNvPr id="17" name="TextBox 16"/>
+          <p:cNvSpPr txBox="1"/>
+          <p:nvPr/>
+        </p:nvSpPr>
+        <p:spPr>
+          <a:xfrm>
+            <a:off x="4700016" y="2871216"/>
+            <a:ext cx="2798064" cy="475488"/>
+          </a:xfrm>
+          <a:prstGeom prst="rect">
+            <a:avLst/>
+          </a:prstGeom>
+          <a:noFill/>
+        </p:spPr>
+        <p:txBody>
+          <a:bodyPr wrap="square" lIns="27432" rIns="27432" tIns="27432" bIns="27432" anchor="ctr">
+            <a:spAutoFit/>
+          </a:bodyPr>
+          <a:lstStyle/>
+          <a:p>
+            <a:pPr algn="l">
+              <a:lnSpc>
+                <a:spcPct val="108000"/>
+              </a:lnSpc>
+              <a:spcAft>
+                <a:spcPts val="0"/>
+              </a:spcAft>
+            </a:pPr>
+            <a:r>
+              <a:rPr sz="1700" b="1">
+                <a:solidFill>
+                  <a:srgbClr val="1A2F37"/>
+                </a:solidFill>
+                <a:latin typeface="Aptos"/>
+              </a:rPr>
+              <a:t>Penjualan Malang</a:t>
+            </a:r>
+          </a:p>
+        </p:txBody>
+      </p:sp>
+      <p:sp>
+        <p:nvSpPr>
+          <p:cNvPr id="18" name="TextBox 17"/>
+          <p:cNvSpPr txBox="1"/>
+          <p:nvPr/>
+        </p:nvSpPr>
+        <p:spPr>
+          <a:xfrm>
+            <a:off x="4700016" y="3401568"/>
+            <a:ext cx="2779776" cy="1097280"/>
+          </a:xfrm>
+          <a:prstGeom prst="rect">
+            <a:avLst/>
+          </a:prstGeom>
+          <a:noFill/>
+        </p:spPr>
+        <p:txBody>
+          <a:bodyPr wrap="square" lIns="27432" rIns="27432" tIns="27432" bIns="27432" anchor="t">
+            <a:spAutoFit/>
+          </a:bodyPr>
+          <a:lstStyle/>
+          <a:p>
+            <a:pPr algn="l">
+              <a:lnSpc>
+                <a:spcPct val="120000"/>
+              </a:lnSpc>
+              <a:spcAft>
+                <a:spcPts val="0"/>
+              </a:spcAft>
+            </a:pPr>
+            <a:r>
+              <a:rPr sz="1400" b="0">
+                <a:solidFill>
+                  <a:srgbClr val="586C71"/>
+                </a:solidFill>
+                <a:latin typeface="Aptos"/>
+              </a:rPr>
+              <a:t>Definisi bisnis, metrik,</a:t>
+            </a:r>
+          </a:p>
+          <a:p>
+            <a:pPr algn="l">
+              <a:lnSpc>
+                <a:spcPct val="120000"/>
+              </a:lnSpc>
+              <a:spcAft>
+                <a:spcPts val="0"/>
+              </a:spcAft>
+            </a:pPr>
+            <a:r>
+              <a:rPr sz="1400" b="0">
+                <a:solidFill>
+                  <a:srgbClr val="586C71"/>
+                </a:solidFill>
+                <a:latin typeface="Aptos"/>
+              </a:rPr>
+              <a:t>lingkup unit</a:t>
+            </a:r>
+          </a:p>
+          <a:p>
+            <a:pPr algn="l">
+              <a:lnSpc>
+                <a:spcPct val="120000"/>
+              </a:lnSpc>
+              <a:spcAft>
+                <a:spcPts val="0"/>
+              </a:spcAft>
+            </a:pPr>
+            <a:r>
+              <a:rPr sz="1400" b="0">
+                <a:solidFill>
+                  <a:srgbClr val="586C71"/>
+                </a:solidFill>
+                <a:latin typeface="Aptos"/>
+              </a:rPr>
+              <a:t>Pemeriksa: manajer.penjualan</a:t>
+            </a:r>
+          </a:p>
+        </p:txBody>
+      </p:sp>
+      <p:sp>
+        <p:nvSpPr>
+          <p:cNvPr id="19" name="Rounded Rectangle 18"/>
+          <p:cNvSpPr/>
+          <p:nvPr/>
+        </p:nvSpPr>
+        <p:spPr>
+          <a:xfrm>
+            <a:off x="8229600" y="2688336"/>
+            <a:ext cx="3218688" cy="1993392"/>
+          </a:xfrm>
+          <a:prstGeom prst="roundRect">
+            <a:avLst>
+              <a:gd name="adj" fmla="val 18000"/>
+            </a:avLst>
+          </a:prstGeom>
+          <a:solidFill>
+            <a:srgbClr val="FFFFFF"/>
+          </a:solidFill>
+          <a:ln w="10160">
+            <a:solidFill>
+              <a:srgbClr val="DBE6E2"/>
+            </a:solidFill>
+          </a:ln>
+        </p:spPr>
+        <p:style>
+          <a:lnRef idx="1">
+            <a:schemeClr val="accent1"/>
+          </a:lnRef>
+          <a:fillRef idx="3">
+            <a:schemeClr val="accent1"/>
+          </a:fillRef>
+          <a:effectRef idx="2">
+            <a:schemeClr val="accent1"/>
+          </a:effectRef>
+          <a:fontRef idx="minor">
+            <a:schemeClr val="lt1"/>
+          </a:fontRef>
+        </p:style>
+        <p:txBody>
+          <a:bodyPr rtlCol="0" anchor="ctr"/>
+          <a:lstStyle/>
+          <a:p>
+            <a:pPr algn="ctr"/>
+          </a:p>
+        </p:txBody>
+      </p:sp>
+      <p:sp>
+        <p:nvSpPr>
+          <p:cNvPr id="20" name="Rounded Rectangle 19"/>
+          <p:cNvSpPr/>
+          <p:nvPr/>
+        </p:nvSpPr>
+        <p:spPr>
+          <a:xfrm>
+            <a:off x="8229600" y="2889504"/>
+            <a:ext cx="54864" cy="1591056"/>
+          </a:xfrm>
+          <a:prstGeom prst="roundRect">
+            <a:avLst>
+              <a:gd name="adj" fmla="val 18000"/>
+            </a:avLst>
+          </a:prstGeom>
+          <a:solidFill>
+            <a:srgbClr val="CF8B3A"/>
+          </a:solidFill>
+          <a:ln>
+            <a:noFill/>
+          </a:ln>
+        </p:spPr>
+        <p:style>
+          <a:lnRef idx="1">
+            <a:schemeClr val="accent1"/>
+          </a:lnRef>
+          <a:fillRef idx="3">
+            <a:schemeClr val="accent1"/>
+          </a:fillRef>
+          <a:effectRef idx="2">
+            <a:schemeClr val="accent1"/>
+          </a:effectRef>
+          <a:fontRef idx="minor">
+            <a:schemeClr val="lt1"/>
+          </a:fontRef>
+        </p:style>
+        <p:txBody>
+          <a:bodyPr rtlCol="0" anchor="ctr"/>
+          <a:lstStyle/>
+          <a:p>
+            <a:pPr algn="ctr"/>
+          </a:p>
+        </p:txBody>
+      </p:sp>
+      <p:sp>
+        <p:nvSpPr>
+          <p:cNvPr id="21" name="TextBox 20"/>
+          <p:cNvSpPr txBox="1"/>
+          <p:nvPr/>
+        </p:nvSpPr>
+        <p:spPr>
+          <a:xfrm>
+            <a:off x="8449056" y="2871216"/>
+            <a:ext cx="2798064" cy="475488"/>
+          </a:xfrm>
+          <a:prstGeom prst="rect">
+            <a:avLst/>
+          </a:prstGeom>
+          <a:noFill/>
+        </p:spPr>
+        <p:txBody>
+          <a:bodyPr wrap="square" lIns="27432" rIns="27432" tIns="27432" bIns="27432" anchor="ctr">
+            <a:spAutoFit/>
+          </a:bodyPr>
+          <a:lstStyle/>
+          <a:p>
+            <a:pPr algn="l">
+              <a:lnSpc>
+                <a:spcPct val="108000"/>
+              </a:lnSpc>
+              <a:spcAft>
+                <a:spcPts val="0"/>
+              </a:spcAft>
+            </a:pPr>
+            <a:r>
+              <a:rPr sz="1700" b="1">
+                <a:solidFill>
+                  <a:srgbClr val="1A2F37"/>
+                </a:solidFill>
+                <a:latin typeface="Aptos"/>
+              </a:rPr>
+              <a:t>Keuangan Surabaya</a:t>
+            </a:r>
+          </a:p>
+        </p:txBody>
+      </p:sp>
+      <p:sp>
+        <p:nvSpPr>
+          <p:cNvPr id="22" name="TextBox 21"/>
+          <p:cNvSpPr txBox="1"/>
+          <p:nvPr/>
+        </p:nvSpPr>
+        <p:spPr>
+          <a:xfrm>
+            <a:off x="8449056" y="3401568"/>
+            <a:ext cx="2779776" cy="1097280"/>
+          </a:xfrm>
+          <a:prstGeom prst="rect">
+            <a:avLst/>
+          </a:prstGeom>
+          <a:noFill/>
+        </p:spPr>
+        <p:txBody>
+          <a:bodyPr wrap="square" lIns="27432" rIns="27432" tIns="27432" bIns="27432" anchor="t">
+            <a:spAutoFit/>
+          </a:bodyPr>
+          <a:lstStyle/>
+          <a:p>
+            <a:pPr algn="l">
+              <a:lnSpc>
+                <a:spcPct val="120000"/>
+              </a:lnSpc>
+              <a:spcAft>
+                <a:spcPts val="0"/>
+              </a:spcAft>
+            </a:pPr>
+            <a:r>
+              <a:rPr sz="1400" b="0">
+                <a:solidFill>
+                  <a:srgbClr val="586C71"/>
+                </a:solidFill>
+                <a:latin typeface="Aptos"/>
+              </a:rPr>
+              <a:t>Kesesuaian data lintas unit</a:t>
+            </a:r>
+          </a:p>
+          <a:p>
+            <a:pPr algn="l">
+              <a:lnSpc>
+                <a:spcPct val="120000"/>
+              </a:lnSpc>
+              <a:spcAft>
+                <a:spcPts val="0"/>
+              </a:spcAft>
+            </a:pPr>
+            <a:r>
+              <a:rPr sz="1400" b="0">
+                <a:solidFill>
+                  <a:srgbClr val="586C71"/>
+                </a:solidFill>
+                <a:latin typeface="Aptos"/>
+              </a:rPr>
+              <a:t>dan aturan pemakaian</a:t>
+            </a:r>
+          </a:p>
+          <a:p>
+            <a:pPr algn="l">
+              <a:lnSpc>
+                <a:spcPct val="120000"/>
+              </a:lnSpc>
+              <a:spcAft>
+                <a:spcPts val="0"/>
+              </a:spcAft>
+            </a:pPr>
+            <a:r>
+              <a:rPr sz="1400" b="0">
+                <a:solidFill>
+                  <a:srgbClr val="586C71"/>
+                </a:solidFill>
+                <a:latin typeface="Aptos"/>
+              </a:rPr>
+              <a:t>Pemeriksa: manajer.keuangan</a:t>
+            </a:r>
+          </a:p>
+        </p:txBody>
+      </p:sp>
+      <p:sp>
+        <p:nvSpPr>
+          <p:cNvPr id="23" name="TextBox 22"/>
+          <p:cNvSpPr txBox="1"/>
+          <p:nvPr/>
+        </p:nvSpPr>
+        <p:spPr>
+          <a:xfrm>
+            <a:off x="4078224" y="3392424"/>
+            <a:ext cx="310896" cy="457200"/>
+          </a:xfrm>
+          <a:prstGeom prst="rect">
+            <a:avLst/>
+          </a:prstGeom>
+          <a:noFill/>
+        </p:spPr>
+        <p:txBody>
+          <a:bodyPr wrap="square" lIns="27432" rIns="27432" tIns="27432" bIns="27432" anchor="ctr">
+            <a:spAutoFit/>
+          </a:bodyPr>
+          <a:lstStyle/>
+          <a:p>
+            <a:pPr algn="ctr">
+              <a:lnSpc>
+                <a:spcPct val="108000"/>
+              </a:lnSpc>
+              <a:spcAft>
+                <a:spcPts val="0"/>
+              </a:spcAft>
+            </a:pPr>
+            <a:r>
+              <a:rPr sz="2300" b="1">
+                <a:solidFill>
+                  <a:srgbClr val="096752"/>
+                </a:solidFill>
+                <a:latin typeface="Aptos"/>
+              </a:rPr>
+              <a:t>+</a:t>
+            </a:r>
+          </a:p>
+        </p:txBody>
+      </p:sp>
+      <p:sp>
+        <p:nvSpPr>
+          <p:cNvPr id="24" name="TextBox 23"/>
+          <p:cNvSpPr txBox="1"/>
+          <p:nvPr/>
+        </p:nvSpPr>
+        <p:spPr>
+          <a:xfrm>
+            <a:off x="7827264" y="3392424"/>
+            <a:ext cx="310896" cy="457200"/>
+          </a:xfrm>
+          <a:prstGeom prst="rect">
+            <a:avLst/>
+          </a:prstGeom>
+          <a:noFill/>
+        </p:spPr>
+        <p:txBody>
+          <a:bodyPr wrap="square" lIns="27432" rIns="27432" tIns="27432" bIns="27432" anchor="ctr">
+            <a:spAutoFit/>
+          </a:bodyPr>
+          <a:lstStyle/>
+          <a:p>
+            <a:pPr algn="ctr">
+              <a:lnSpc>
+                <a:spcPct val="108000"/>
+              </a:lnSpc>
+              <a:spcAft>
+                <a:spcPts val="0"/>
+              </a:spcAft>
+            </a:pPr>
+            <a:r>
+              <a:rPr sz="2300" b="1">
+                <a:solidFill>
+                  <a:srgbClr val="096752"/>
+                </a:solidFill>
+                <a:latin typeface="Aptos"/>
+              </a:rPr>
+              <a:t>+</a:t>
+            </a:r>
+          </a:p>
+        </p:txBody>
+      </p:sp>
+      <p:sp>
+        <p:nvSpPr>
+          <p:cNvPr id="25" name="Rounded Rectangle 24"/>
+          <p:cNvSpPr/>
+          <p:nvPr/>
+        </p:nvSpPr>
+        <p:spPr>
+          <a:xfrm>
+            <a:off x="1426464" y="5166360"/>
+            <a:ext cx="9308592" cy="713232"/>
+          </a:xfrm>
+          <a:prstGeom prst="roundRect">
+            <a:avLst>
+              <a:gd name="adj" fmla="val 18000"/>
+            </a:avLst>
+          </a:prstGeom>
+          <a:solidFill>
+            <a:srgbClr val="CCEEE2"/>
+          </a:solidFill>
+          <a:ln>
+            <a:noFill/>
+          </a:ln>
+        </p:spPr>
+        <p:style>
+          <a:lnRef idx="1">
+            <a:schemeClr val="accent1"/>
+          </a:lnRef>
+          <a:fillRef idx="3">
+            <a:schemeClr val="accent1"/>
+          </a:fillRef>
+          <a:effectRef idx="2">
+            <a:schemeClr val="accent1"/>
+          </a:effectRef>
+          <a:fontRef idx="minor">
+            <a:schemeClr val="lt1"/>
+          </a:fontRef>
+        </p:style>
+        <p:txBody>
+          <a:bodyPr rtlCol="0" anchor="ctr"/>
+          <a:lstStyle/>
+          <a:p>
+            <a:pPr algn="ctr"/>
+          </a:p>
+        </p:txBody>
+      </p:sp>
+      <p:sp>
+        <p:nvSpPr>
+          <p:cNvPr id="26" name="TextBox 25"/>
+          <p:cNvSpPr txBox="1"/>
+          <p:nvPr/>
+        </p:nvSpPr>
+        <p:spPr>
+          <a:xfrm>
+            <a:off x="1645920" y="5330952"/>
+            <a:ext cx="8887968" cy="384048"/>
+          </a:xfrm>
+          <a:prstGeom prst="rect">
+            <a:avLst/>
+          </a:prstGeom>
+          <a:noFill/>
+        </p:spPr>
+        <p:txBody>
+          <a:bodyPr wrap="square" lIns="27432" rIns="27432" tIns="27432" bIns="27432" anchor="ctr">
+            <a:spAutoFit/>
+          </a:bodyPr>
+          <a:lstStyle/>
+          <a:p>
+            <a:pPr algn="ctr">
+              <a:lnSpc>
+                <a:spcPct val="108000"/>
+              </a:lnSpc>
+              <a:spcAft>
+                <a:spcPts val="0"/>
+              </a:spcAft>
+            </a:pPr>
+            <a:r>
+              <a:rPr sz="1540" b="1">
+                <a:solidFill>
+                  <a:srgbClr val="096752"/>
+                </a:solidFill>
+                <a:latin typeface="Aptos"/>
+              </a:rPr>
+              <a:t>Semua setuju pada revisi yang sama  →  deploy  →  data tersedia sesuai policy akses</a:t>
+            </a:r>
+          </a:p>
+        </p:txBody>
+      </p:sp>
+    </p:spTree>
+  </p:cSld>
+  <p:clrMapOvr>
+    <a:masterClrMapping/>
+  </p:clrMapOvr>
+</p:sld>
+</file>
+
+<file path=ppt/slides/slide21.xml><?xml version="1.0" encoding="utf-8"?>
+<p:sld xmlns:a="http://schemas.openxmlformats.org/drawingml/2006/main" xmlns:p="http://schemas.openxmlformats.org/presentationml/2006/main" xmlns:r="http://schemas.openxmlformats.org/officeDocument/2006/relationships">
+  <p:cSld>
+    <p:spTree>
+      <p:nvGrpSpPr>
+        <p:cNvPr id="1" name=""/>
+        <p:cNvGrpSpPr/>
+        <p:nvPr/>
+      </p:nvGrpSpPr>
+      <p:grpSpPr/>
+      <p:sp>
+        <p:nvSpPr>
+          <p:cNvPr id="2" name="Rectangle 1"/>
+          <p:cNvSpPr/>
+          <p:nvPr/>
+        </p:nvSpPr>
+        <p:spPr>
+          <a:xfrm>
+            <a:off x="0" y="0"/>
+            <a:ext cx="12191695" cy="6858000"/>
+          </a:xfrm>
+          <a:prstGeom prst="rect">
+            <a:avLst/>
+          </a:prstGeom>
+          <a:solidFill>
+            <a:srgbClr val="0C1C29"/>
+          </a:solidFill>
+          <a:ln>
+            <a:noFill/>
+          </a:ln>
+        </p:spPr>
+        <p:style>
+          <a:lnRef idx="1">
+            <a:schemeClr val="accent1"/>
+          </a:lnRef>
+          <a:fillRef idx="3">
+            <a:schemeClr val="accent1"/>
+          </a:fillRef>
+          <a:effectRef idx="2">
+            <a:schemeClr val="accent1"/>
+          </a:effectRef>
+          <a:fontRef idx="minor">
+            <a:schemeClr val="lt1"/>
+          </a:fontRef>
+        </p:style>
+        <p:txBody>
+          <a:bodyPr rtlCol="0" anchor="ctr"/>
+          <a:lstStyle/>
+          <a:p>
+            <a:pPr algn="ctr"/>
+          </a:p>
+        </p:txBody>
+      </p:sp>
+      <p:sp>
+        <p:nvSpPr>
+          <p:cNvPr id="3" name="Oval 2"/>
+          <p:cNvSpPr/>
+          <p:nvPr/>
+        </p:nvSpPr>
+        <p:spPr>
+          <a:xfrm>
+            <a:off x="9235440" y="-1097280"/>
+            <a:ext cx="4023360" cy="4023360"/>
+          </a:xfrm>
+          <a:prstGeom prst="ellipse">
+            <a:avLst/>
+          </a:prstGeom>
+          <a:solidFill>
+            <a:srgbClr val="122B37"/>
+          </a:solidFill>
+          <a:ln>
+            <a:noFill/>
+          </a:ln>
+        </p:spPr>
+        <p:style>
+          <a:lnRef idx="1">
+            <a:schemeClr val="accent1"/>
+          </a:lnRef>
+          <a:fillRef idx="3">
+            <a:schemeClr val="accent1"/>
+          </a:fillRef>
+          <a:effectRef idx="2">
+            <a:schemeClr val="accent1"/>
+          </a:effectRef>
+          <a:fontRef idx="minor">
+            <a:schemeClr val="lt1"/>
+          </a:fontRef>
+        </p:style>
+        <p:txBody>
+          <a:bodyPr rtlCol="0" anchor="ctr"/>
+          <a:lstStyle/>
+          <a:p>
+            <a:pPr algn="ctr"/>
+          </a:p>
+        </p:txBody>
+      </p:sp>
+      <p:sp>
+        <p:nvSpPr>
+          <p:cNvPr id="4" name="Oval 3"/>
+          <p:cNvSpPr/>
+          <p:nvPr/>
+        </p:nvSpPr>
+        <p:spPr>
+          <a:xfrm>
+            <a:off x="-1097280" y="5303520"/>
+            <a:ext cx="2926080" cy="2926080"/>
+          </a:xfrm>
+          <a:prstGeom prst="ellipse">
+            <a:avLst/>
+          </a:prstGeom>
+          <a:solidFill>
+            <a:srgbClr val="122B37"/>
+          </a:solidFill>
+          <a:ln>
+            <a:noFill/>
+          </a:ln>
+        </p:spPr>
+        <p:style>
+          <a:lnRef idx="1">
+            <a:schemeClr val="accent1"/>
+          </a:lnRef>
+          <a:fillRef idx="3">
+            <a:schemeClr val="accent1"/>
+          </a:fillRef>
+          <a:effectRef idx="2">
+            <a:schemeClr val="accent1"/>
+          </a:effectRef>
+          <a:fontRef idx="minor">
+            <a:schemeClr val="lt1"/>
+          </a:fontRef>
+        </p:style>
+        <p:txBody>
+          <a:bodyPr rtlCol="0" anchor="ctr"/>
+          <a:lstStyle/>
+          <a:p>
+            <a:pPr algn="ctr"/>
+          </a:p>
+        </p:txBody>
+      </p:sp>
+      <p:sp>
+        <p:nvSpPr>
+          <p:cNvPr id="5" name="TextBox 4"/>
+          <p:cNvSpPr txBox="1"/>
+          <p:nvPr/>
+        </p:nvSpPr>
+        <p:spPr>
+          <a:xfrm>
+            <a:off x="658368" y="338328"/>
+            <a:ext cx="9601200" cy="256032"/>
+          </a:xfrm>
+          <a:prstGeom prst="rect">
+            <a:avLst/>
+          </a:prstGeom>
+          <a:noFill/>
+        </p:spPr>
+        <p:txBody>
+          <a:bodyPr wrap="square" lIns="27432" rIns="27432" tIns="27432" bIns="27432" anchor="ctr">
+            <a:spAutoFit/>
+          </a:bodyPr>
+          <a:lstStyle/>
+          <a:p>
+            <a:pPr algn="l">
+              <a:lnSpc>
+                <a:spcPct val="108000"/>
+              </a:lnSpc>
+              <a:spcAft>
+                <a:spcPts val="0"/>
+              </a:spcAft>
+            </a:pPr>
+            <a:r>
+              <a:rPr sz="1050" b="1">
+                <a:solidFill>
+                  <a:srgbClr val="CCEEE2"/>
+                </a:solidFill>
+                <a:latin typeface="Aptos"/>
+              </a:rPr>
+              <a:t>PENUTUP</a:t>
+            </a:r>
+          </a:p>
+        </p:txBody>
+      </p:sp>
+      <p:sp>
+        <p:nvSpPr>
+          <p:cNvPr id="6" name="TextBox 5"/>
+          <p:cNvSpPr txBox="1"/>
+          <p:nvPr/>
+        </p:nvSpPr>
+        <p:spPr>
+          <a:xfrm>
+            <a:off x="658368" y="713232"/>
+            <a:ext cx="10835640" cy="621792"/>
+          </a:xfrm>
+          <a:prstGeom prst="rect">
+            <a:avLst/>
+          </a:prstGeom>
+          <a:noFill/>
+        </p:spPr>
+        <p:txBody>
+          <a:bodyPr wrap="square" lIns="27432" rIns="27432" tIns="27432" bIns="27432" anchor="ctr">
+            <a:spAutoFit/>
+          </a:bodyPr>
+          <a:lstStyle/>
+          <a:p>
+            <a:pPr algn="l">
+              <a:lnSpc>
+                <a:spcPct val="108000"/>
+              </a:lnSpc>
+              <a:spcAft>
+                <a:spcPts val="0"/>
+              </a:spcAft>
+            </a:pPr>
+            <a:r>
+              <a:rPr sz="2800" b="1">
+                <a:solidFill>
+                  <a:srgbClr val="FFFFFF"/>
+                </a:solidFill>
+                <a:latin typeface="Aptos"/>
+              </a:rPr>
+              <a:t>Pesan utama</a:t>
+            </a:r>
+          </a:p>
+        </p:txBody>
+      </p:sp>
+      <p:cxnSp>
+        <p:nvCxnSpPr>
+          <p:cNvPr id="7" name="Connector 6"/>
+          <p:cNvCxnSpPr/>
+          <p:nvPr/>
+        </p:nvCxnSpPr>
+        <p:spPr>
+          <a:xfrm>
+            <a:off x="676656" y="6492240"/>
+            <a:ext cx="10799064" cy="0"/>
+          </a:xfrm>
+          <a:prstGeom prst="line">
+            <a:avLst/>
+          </a:prstGeom>
+          <a:ln w="16510">
+            <a:solidFill>
+              <a:srgbClr val="4D6868"/>
+            </a:solidFill>
+          </a:ln>
+        </p:spPr>
+        <p:style>
+          <a:lnRef idx="2">
+            <a:schemeClr val="accent1"/>
+          </a:lnRef>
+          <a:fillRef idx="0">
+            <a:schemeClr val="accent1"/>
+          </a:fillRef>
+          <a:effectRef idx="1">
+            <a:schemeClr val="accent1"/>
+          </a:effectRef>
+          <a:fontRef idx="minor">
+            <a:schemeClr val="tx1"/>
+          </a:fontRef>
+        </p:style>
+      </p:cxnSp>
+      <p:sp>
+        <p:nvSpPr>
+          <p:cNvPr id="8" name="TextBox 7"/>
+          <p:cNvSpPr txBox="1"/>
+          <p:nvPr/>
+        </p:nvSpPr>
+        <p:spPr>
+          <a:xfrm>
+            <a:off x="676656" y="6537960"/>
+            <a:ext cx="7132320" cy="164592"/>
+          </a:xfrm>
+          <a:prstGeom prst="rect">
+            <a:avLst/>
+          </a:prstGeom>
+          <a:noFill/>
+        </p:spPr>
+        <p:txBody>
+          <a:bodyPr wrap="square" lIns="27432" rIns="27432" tIns="27432" bIns="27432" anchor="ctr">
+            <a:spAutoFit/>
+          </a:bodyPr>
+          <a:lstStyle/>
+          <a:p>
+            <a:pPr algn="l">
+              <a:lnSpc>
+                <a:spcPct val="108000"/>
+              </a:lnSpc>
+              <a:spcAft>
+                <a:spcPts val="0"/>
+              </a:spcAft>
+            </a:pPr>
+            <a:r>
+              <a:rPr sz="850" b="0">
+                <a:solidFill>
+                  <a:srgbClr val="CCEEE2"/>
+                </a:solidFill>
+                <a:latin typeface="Aptos"/>
+              </a:rPr>
+              <a:t>GOOGLE SHEET AI  ·  TINJAUAN APLIKASI</a:t>
+            </a:r>
+          </a:p>
+        </p:txBody>
+      </p:sp>
+      <p:sp>
+        <p:nvSpPr>
+          <p:cNvPr id="9" name="TextBox 8"/>
+          <p:cNvSpPr txBox="1"/>
+          <p:nvPr/>
+        </p:nvSpPr>
+        <p:spPr>
+          <a:xfrm>
+            <a:off x="10972800" y="6519672"/>
+            <a:ext cx="502920" cy="192024"/>
+          </a:xfrm>
+          <a:prstGeom prst="rect">
+            <a:avLst/>
+          </a:prstGeom>
+          <a:noFill/>
+        </p:spPr>
+        <p:txBody>
+          <a:bodyPr wrap="square" lIns="27432" rIns="27432" tIns="27432" bIns="27432" anchor="ctr">
+            <a:spAutoFit/>
+          </a:bodyPr>
+          <a:lstStyle/>
+          <a:p>
+            <a:pPr algn="r">
+              <a:lnSpc>
+                <a:spcPct val="108000"/>
+              </a:lnSpc>
+              <a:spcAft>
+                <a:spcPts val="0"/>
+              </a:spcAft>
+            </a:pPr>
+            <a:r>
+              <a:rPr sz="950" b="0">
+                <a:solidFill>
+                  <a:srgbClr val="CCEEE2"/>
+                </a:solidFill>
+                <a:latin typeface="Aptos"/>
+              </a:rPr>
+              <a:t>21</a:t>
+            </a:r>
+          </a:p>
+        </p:txBody>
+      </p:sp>
+      <p:sp>
+        <p:nvSpPr>
+          <p:cNvPr id="10" name="TextBox 9"/>
+          <p:cNvSpPr txBox="1"/>
+          <p:nvPr/>
+        </p:nvSpPr>
+        <p:spPr>
+          <a:xfrm>
+            <a:off x="777240" y="1874519"/>
+            <a:ext cx="9738360" cy="1472184"/>
+          </a:xfrm>
+          <a:prstGeom prst="rect">
+            <a:avLst/>
+          </a:prstGeom>
+          <a:noFill/>
+        </p:spPr>
+        <p:txBody>
+          <a:bodyPr wrap="square" lIns="27432" rIns="27432" tIns="27432" bIns="27432" anchor="t">
+            <a:spAutoFit/>
+          </a:bodyPr>
+          <a:lstStyle/>
+          <a:p>
+            <a:pPr algn="l">
+              <a:lnSpc>
+                <a:spcPct val="108000"/>
+              </a:lnSpc>
+              <a:spcAft>
+                <a:spcPts val="0"/>
+              </a:spcAft>
+            </a:pPr>
+            <a:r>
+              <a:rPr sz="3000" b="1">
+                <a:solidFill>
+                  <a:srgbClr val="FFFFFF"/>
+                </a:solidFill>
+                <a:latin typeface="Aptos"/>
+              </a:rPr>
+              <a:t>Google Sheet tetap menjadi titik awal.</a:t>
+            </a:r>
+          </a:p>
+          <a:p>
+            <a:pPr algn="l">
+              <a:lnSpc>
+                <a:spcPct val="108000"/>
+              </a:lnSpc>
+              <a:spcAft>
+                <a:spcPts val="0"/>
+              </a:spcAft>
+            </a:pPr>
+            <a:r>
+              <a:rPr sz="3000" b="1">
+                <a:solidFill>
+                  <a:srgbClr val="FFFFFF"/>
+                </a:solidFill>
+                <a:latin typeface="Aptos"/>
+              </a:rPr>
+              <a:t>Kepercayaan dibangun melalui proses.</a:t>
+            </a:r>
+          </a:p>
+        </p:txBody>
+      </p:sp>
+      <p:sp>
+        <p:nvSpPr>
+          <p:cNvPr id="11" name="TextBox 10"/>
+          <p:cNvSpPr txBox="1"/>
+          <p:nvPr/>
+        </p:nvSpPr>
+        <p:spPr>
+          <a:xfrm>
+            <a:off x="832104" y="3895344"/>
+            <a:ext cx="10515600" cy="731520"/>
+          </a:xfrm>
+          <a:prstGeom prst="rect">
+            <a:avLst/>
+          </a:prstGeom>
+          <a:noFill/>
+        </p:spPr>
+        <p:txBody>
+          <a:bodyPr wrap="square" lIns="27432" rIns="27432" tIns="27432" bIns="27432" anchor="ctr">
+            <a:spAutoFit/>
+          </a:bodyPr>
+          <a:lstStyle/>
+          <a:p>
+            <a:pPr algn="l">
+              <a:lnSpc>
+                <a:spcPct val="108000"/>
+              </a:lnSpc>
+              <a:spcAft>
+                <a:spcPts val="0"/>
+              </a:spcAft>
+            </a:pPr>
+            <a:r>
+              <a:rPr sz="2000" b="1">
+                <a:solidFill>
+                  <a:srgbClr val="CCEEE2"/>
+                </a:solidFill>
+                <a:latin typeface="Aptos"/>
+              </a:rPr>
+              <a:t>Daftarkan  →  Maknai  →  Validasi  →  Setujui  →  Gunakan</a:t>
+            </a:r>
+          </a:p>
+        </p:txBody>
+      </p:sp>
+      <p:sp>
+        <p:nvSpPr>
+          <p:cNvPr id="12" name="TextBox 11"/>
+          <p:cNvSpPr txBox="1"/>
+          <p:nvPr/>
+        </p:nvSpPr>
+        <p:spPr>
+          <a:xfrm>
+            <a:off x="832104" y="5193792"/>
+            <a:ext cx="10241280" cy="576072"/>
+          </a:xfrm>
+          <a:prstGeom prst="rect">
+            <a:avLst/>
+          </a:prstGeom>
+          <a:noFill/>
+        </p:spPr>
+        <p:txBody>
+          <a:bodyPr wrap="square" lIns="27432" rIns="27432" tIns="27432" bIns="27432" anchor="ctr">
+            <a:spAutoFit/>
+          </a:bodyPr>
+          <a:lstStyle/>
+          <a:p>
+            <a:pPr algn="l">
+              <a:lnSpc>
+                <a:spcPct val="108000"/>
+              </a:lnSpc>
+              <a:spcAft>
+                <a:spcPts val="0"/>
+              </a:spcAft>
+            </a:pPr>
+            <a:r>
+              <a:rPr sz="1000" b="0">
+                <a:solidFill>
+                  <a:srgbClr val="CCEEE2"/>
+                </a:solidFill>
+                <a:latin typeface="Aptos"/>
+              </a:rPr>
+              <a:t>Sumber: USER_GUIDE_END_TO_END.md · ACCESS_JURISDICTION_BE16.md ·</a:t>
+            </a:r>
+          </a:p>
+          <a:p>
+            <a:pPr algn="l">
+              <a:lnSpc>
+                <a:spcPct val="108000"/>
+              </a:lnSpc>
+              <a:spcAft>
+                <a:spcPts val="0"/>
+              </a:spcAft>
+            </a:pPr>
+            <a:r>
+              <a:rPr sz="1000" b="0">
+                <a:solidFill>
+                  <a:srgbClr val="CCEEE2"/>
+                </a:solidFill>
+                <a:latin typeface="Aptos"/>
+              </a:rPr>
+              <a:t>MASTER_DATA_DAN_VALIDASI_IMPORT.md · CONTOH_ISIAN_APLIKASI.md · AI_USER_HELP.md</a:t>
             </a:r>
           </a:p>
         </p:txBody>

</xml_diff>